<commit_message>
feat: fixed content & updated metadata, template file
</commit_message>
<xml_diff>
--- a/workflows/mol-quarterly/template.pptx
+++ b/workflows/mol-quarterly/template.pptx
@@ -12,7 +12,7 @@
     <p:sldId id="257" r:id="rId3"/>
     <p:sldId id="265" r:id="rId4"/>
     <p:sldId id="261" r:id="rId5"/>
-    <p:sldId id="262" r:id="rId6"/>
+    <p:sldId id="266" r:id="rId6"/>
     <p:sldId id="264" r:id="rId7"/>
     <p:sldId id="259" r:id="rId8"/>
   </p:sldIdLst>
@@ -20,7 +20,7 @@
   <p:notesSz cx="6858000" cy="9144000"/>
   <p:embeddedFontLst>
     <p:embeddedFont>
-      <p:font typeface="Helvetica Neue" panose="020B0604020202020204" charset="0"/>
+      <p:font typeface="Helvetica Neue" panose="02000503000000020004" pitchFamily="2" charset="0"/>
       <p:regular r:id="rId10"/>
       <p:bold r:id="rId11"/>
       <p:italic r:id="rId12"/>
@@ -270,7 +270,7 @@
 <file path=ppt/charts/chart1.xml><?xml version="1.0" encoding="utf-8"?>
 <c:chartSpace xmlns:c="http://schemas.openxmlformats.org/drawingml/2006/chart" xmlns:a="http://schemas.openxmlformats.org/drawingml/2006/main" xmlns:r="http://schemas.openxmlformats.org/officeDocument/2006/relationships" xmlns:c16r2="http://schemas.microsoft.com/office/drawing/2015/06/chart">
   <c:date1904 val="0"/>
-  <c:lang val="hu-HU"/>
+  <c:lang val="en-GB"/>
   <c:roundedCorners val="0"/>
   <mc:AlternateContent xmlns:mc="http://schemas.openxmlformats.org/markup-compatibility/2006">
     <mc:Choice xmlns:c14="http://schemas.microsoft.com/office/drawing/2007/8/2/chart" Requires="c14">
@@ -288,10 +288,10 @@
           <c:layoutTarget val="inner"/>
           <c:xMode val="edge"/>
           <c:yMode val="edge"/>
-          <c:x val="2.1022009758305576E-2"/>
-          <c:y val="0.25918078834001845"/>
-          <c:w val="0.95795598048338881"/>
-          <c:h val="0.42183018370853015"/>
+          <c:x val="2.1043977091740444E-2"/>
+          <c:y val="0.22002044284429578"/>
+          <c:w val="0.95791204581651912"/>
+          <c:h val="0.43471440653541038"/>
         </c:manualLayout>
       </c:layout>
       <c:barChart>
@@ -301,6 +301,17 @@
         <c:ser>
           <c:idx val="0"/>
           <c:order val="0"/>
+          <c:tx>
+            <c:strRef>
+              <c:f>Sheet1!$B$1</c:f>
+              <c:strCache>
+                <c:ptCount val="1"/>
+                <c:pt idx="0">
+                  <c:v>Series 1</c:v>
+                </c:pt>
+              </c:strCache>
+            </c:strRef>
+          </c:tx>
           <c:spPr>
             <a:solidFill>
               <a:schemeClr val="accent1"/>
@@ -328,7 +339,7 @@
             </c:spPr>
             <c:extLst>
               <c:ext xmlns:c16="http://schemas.microsoft.com/office/drawing/2014/chart" uri="{C3380CC4-5D6E-409C-BE32-E72D297353CC}">
-                <c16:uniqueId val="{00000003-7282-CF46-8ED7-62AD0FCCDF53}"/>
+                <c16:uniqueId val="{00000001-05AD-3A46-AC49-8D9B3221D2C9}"/>
               </c:ext>
             </c:extLst>
           </c:dPt>
@@ -338,7 +349,7 @@
             <c:bubble3D val="0"/>
             <c:spPr>
               <a:solidFill>
-                <a:srgbClr val="E0011D"/>
+                <a:srgbClr val="E00120"/>
               </a:solidFill>
               <a:ln>
                 <a:noFill/>
@@ -347,7 +358,7 @@
             </c:spPr>
             <c:extLst>
               <c:ext xmlns:c16="http://schemas.microsoft.com/office/drawing/2014/chart" uri="{C3380CC4-5D6E-409C-BE32-E72D297353CC}">
-                <c16:uniqueId val="{00000002-7282-CF46-8ED7-62AD0FCCDF53}"/>
+                <c16:uniqueId val="{00000003-05AD-3A46-AC49-8D9B3221D2C9}"/>
               </c:ext>
             </c:extLst>
           </c:dPt>
@@ -366,7 +377,7 @@
             </c:spPr>
             <c:extLst>
               <c:ext xmlns:c16="http://schemas.microsoft.com/office/drawing/2014/chart" uri="{C3380CC4-5D6E-409C-BE32-E72D297353CC}">
-                <c16:uniqueId val="{00000001-7282-CF46-8ED7-62AD0FCCDF53}"/>
+                <c16:uniqueId val="{00000005-05AD-3A46-AC49-8D9B3221D2C9}"/>
               </c:ext>
             </c:extLst>
           </c:dPt>
@@ -375,7 +386,7 @@
               <c:idx val="0"/>
               <c:spPr>
                 <a:solidFill>
-                  <a:schemeClr val="bg1"/>
+                  <a:schemeClr val="lt1"/>
                 </a:solidFill>
                 <a:ln>
                   <a:noFill/>
@@ -383,8 +394,8 @@
                 <a:effectLst/>
               </c:spPr>
               <c:txPr>
-                <a:bodyPr rot="0" spcFirstLastPara="1" vertOverflow="overflow" horzOverflow="overflow" vert="horz" wrap="square" lIns="38100" tIns="19050" rIns="38100" bIns="19050" anchor="ctr" anchorCtr="1">
-                  <a:noAutofit/>
+                <a:bodyPr rot="0" spcFirstLastPara="1" vertOverflow="ellipsis" vert="horz" wrap="square" lIns="38100" tIns="19050" rIns="38100" bIns="19050" anchor="ctr" anchorCtr="1">
+                  <a:spAutoFit/>
                 </a:bodyPr>
                 <a:lstStyle/>
                 <a:p>
@@ -404,7 +415,6 @@
                   <a:endParaRPr lang="en-HU"/>
                 </a:p>
               </c:txPr>
-              <c:dLblPos val="ctr"/>
               <c:showLegendKey val="0"/>
               <c:showVal val="1"/>
               <c:showCatName val="0"/>
@@ -412,32 +422,17 @@
               <c:showPercent val="0"/>
               <c:showBubbleSize val="0"/>
               <c:extLst>
-                <c:ext xmlns:c15="http://schemas.microsoft.com/office/drawing/2012/chart" uri="{CE6537A1-D6FC-4f65-9D91-7224C49458BB}">
-                  <c15:spPr xmlns:c15="http://schemas.microsoft.com/office/drawing/2012/chart">
-                    <a:prstGeom prst="rect">
-                      <a:avLst/>
-                    </a:prstGeom>
-                    <a:noFill/>
-                    <a:ln>
-                      <a:noFill/>
-                    </a:ln>
-                  </c15:spPr>
-                  <c15:layout>
-                    <c:manualLayout>
-                      <c:w val="3.2503608502462443E-2"/>
-                      <c:h val="0.20036882706314954"/>
-                    </c:manualLayout>
-                  </c15:layout>
-                </c:ext>
                 <c:ext xmlns:c16="http://schemas.microsoft.com/office/drawing/2014/chart" uri="{C3380CC4-5D6E-409C-BE32-E72D297353CC}">
-                  <c16:uniqueId val="{00000003-7282-CF46-8ED7-62AD0FCCDF53}"/>
+                  <c16:uniqueId val="{00000001-05AD-3A46-AC49-8D9B3221D2C9}"/>
                 </c:ext>
               </c:extLst>
             </c:dLbl>
             <c:dLbl>
               <c:idx val="1"/>
               <c:spPr>
-                <a:noFill/>
+                <a:solidFill>
+                  <a:srgbClr val="E00120"/>
+                </a:solidFill>
                 <a:ln>
                   <a:noFill/>
                 </a:ln>
@@ -470,14 +465,16 @@
               <c:showBubbleSize val="0"/>
               <c:extLst>
                 <c:ext xmlns:c16="http://schemas.microsoft.com/office/drawing/2014/chart" uri="{C3380CC4-5D6E-409C-BE32-E72D297353CC}">
-                  <c16:uniqueId val="{00000002-7282-CF46-8ED7-62AD0FCCDF53}"/>
+                  <c16:uniqueId val="{00000003-05AD-3A46-AC49-8D9B3221D2C9}"/>
                 </c:ext>
               </c:extLst>
             </c:dLbl>
             <c:dLbl>
               <c:idx val="2"/>
               <c:spPr>
-                <a:noFill/>
+                <a:solidFill>
+                  <a:srgbClr val="99001E"/>
+                </a:solidFill>
                 <a:ln>
                   <a:noFill/>
                 </a:ln>
@@ -510,7 +507,7 @@
               <c:showBubbleSize val="0"/>
               <c:extLst>
                 <c:ext xmlns:c16="http://schemas.microsoft.com/office/drawing/2014/chart" uri="{C3380CC4-5D6E-409C-BE32-E72D297353CC}">
-                  <c16:uniqueId val="{00000001-7282-CF46-8ED7-62AD0FCCDF53}"/>
+                  <c16:uniqueId val="{00000005-05AD-3A46-AC49-8D9B3221D2C9}"/>
                 </c:ext>
               </c:extLst>
             </c:dLbl>
@@ -572,42 +569,42 @@
           </c:dLbls>
           <c:cat>
             <c:strRef>
-              <c:f>'Net Financials'!$A$5:$A$7</c:f>
+              <c:f>Sheet1!$A$2:$A$4</c:f>
               <c:strCache>
                 <c:ptCount val="3"/>
                 <c:pt idx="0">
-                  <c:v>Q3 2024</c:v>
+                  <c:v>Q4 2024</c:v>
                 </c:pt>
                 <c:pt idx="1">
-                  <c:v>Q2 2025</c:v>
+                  <c:v>Q3 2025</c:v>
                 </c:pt>
                 <c:pt idx="2">
-                  <c:v>Q3 2025</c:v>
+                  <c:v>Q4 2025</c:v>
                 </c:pt>
               </c:strCache>
             </c:strRef>
           </c:cat>
           <c:val>
             <c:numRef>
-              <c:f>'Net Financials'!$B$5:$B$7</c:f>
+              <c:f>Sheet1!$B$2:$B$4</c:f>
               <c:numCache>
                 <c:formatCode>General</c:formatCode>
                 <c:ptCount val="3"/>
                 <c:pt idx="0">
-                  <c:v>-18</c:v>
+                  <c:v>0</c:v>
                 </c:pt>
                 <c:pt idx="1">
-                  <c:v>-74</c:v>
+                  <c:v>0</c:v>
                 </c:pt>
                 <c:pt idx="2">
-                  <c:v>-90</c:v>
+                  <c:v>0</c:v>
                 </c:pt>
               </c:numCache>
             </c:numRef>
           </c:val>
           <c:extLst>
             <c:ext xmlns:c16="http://schemas.microsoft.com/office/drawing/2014/chart" uri="{C3380CC4-5D6E-409C-BE32-E72D297353CC}">
-              <c16:uniqueId val="{00000000-7282-CF46-8ED7-62AD0FCCDF53}"/>
+              <c16:uniqueId val="{00000006-05AD-3A46-AC49-8D9B3221D2C9}"/>
             </c:ext>
           </c:extLst>
         </c:ser>
@@ -619,13 +616,13 @@
           <c:showPercent val="0"/>
           <c:showBubbleSize val="0"/>
         </c:dLbls>
-        <c:gapWidth val="76"/>
+        <c:gapWidth val="75"/>
         <c:overlap val="100"/>
-        <c:axId val="1272050816"/>
-        <c:axId val="1272052608"/>
+        <c:axId val="1404788159"/>
+        <c:axId val="1404789951"/>
       </c:barChart>
       <c:catAx>
-        <c:axId val="1272050816"/>
+        <c:axId val="1404788159"/>
         <c:scaling>
           <c:orientation val="minMax"/>
         </c:scaling>
@@ -646,7 +643,7 @@
           <a:effectLst/>
         </c:spPr>
         <c:txPr>
-          <a:bodyPr rot="-60000000" spcFirstLastPara="1" vertOverflow="ellipsis" vert="horz" wrap="square" anchor="t" anchorCtr="0"/>
+          <a:bodyPr rot="-60000000" spcFirstLastPara="1" vertOverflow="ellipsis" vert="horz" wrap="square" anchor="ctr" anchorCtr="0"/>
           <a:lstStyle/>
           <a:p>
             <a:pPr>
@@ -662,7 +659,7 @@
             <a:endParaRPr lang="en-HU"/>
           </a:p>
         </c:txPr>
-        <c:crossAx val="1272052608"/>
+        <c:crossAx val="1404789951"/>
         <c:crosses val="autoZero"/>
         <c:auto val="1"/>
         <c:lblAlgn val="ctr"/>
@@ -670,7 +667,7 @@
         <c:noMultiLvlLbl val="0"/>
       </c:catAx>
       <c:valAx>
-        <c:axId val="1272052608"/>
+        <c:axId val="1404789951"/>
         <c:scaling>
           <c:orientation val="minMax"/>
         </c:scaling>
@@ -680,7 +677,7 @@
         <c:majorTickMark val="none"/>
         <c:minorTickMark val="none"/>
         <c:tickLblPos val="nextTo"/>
-        <c:crossAx val="1272050816"/>
+        <c:crossAx val="1404788159"/>
         <c:crosses val="autoZero"/>
         <c:crossBetween val="between"/>
       </c:valAx>
@@ -729,7 +726,7 @@
 <file path=ppt/charts/chart2.xml><?xml version="1.0" encoding="utf-8"?>
 <c:chartSpace xmlns:c="http://schemas.openxmlformats.org/drawingml/2006/chart" xmlns:a="http://schemas.openxmlformats.org/drawingml/2006/main" xmlns:r="http://schemas.openxmlformats.org/officeDocument/2006/relationships" xmlns:c16r2="http://schemas.microsoft.com/office/drawing/2015/06/chart">
   <c:date1904 val="0"/>
-  <c:lang val="hu-HU"/>
+  <c:lang val="en-GB"/>
   <c:roundedCorners val="0"/>
   <mc:AlternateContent xmlns:mc="http://schemas.openxmlformats.org/markup-compatibility/2006">
     <mc:Choice xmlns:c14="http://schemas.microsoft.com/office/drawing/2007/8/2/chart" Requires="c14">
@@ -747,10 +744,10 @@
           <c:layoutTarget val="inner"/>
           <c:xMode val="edge"/>
           <c:yMode val="edge"/>
-          <c:x val="2.1022009758305576E-2"/>
-          <c:y val="0.25918078834001845"/>
-          <c:w val="0.95795598048338881"/>
-          <c:h val="0.42183018370853015"/>
+          <c:x val="2.1043977091740444E-2"/>
+          <c:y val="0.22002044284429578"/>
+          <c:w val="0.95791204581651912"/>
+          <c:h val="0.43471440653541038"/>
         </c:manualLayout>
       </c:layout>
       <c:barChart>
@@ -760,6 +757,17 @@
         <c:ser>
           <c:idx val="0"/>
           <c:order val="0"/>
+          <c:tx>
+            <c:strRef>
+              <c:f>Sheet1!$B$1</c:f>
+              <c:strCache>
+                <c:ptCount val="1"/>
+                <c:pt idx="0">
+                  <c:v>Series 1</c:v>
+                </c:pt>
+              </c:strCache>
+            </c:strRef>
+          </c:tx>
           <c:spPr>
             <a:solidFill>
               <a:schemeClr val="accent1"/>
@@ -787,7 +795,7 @@
             </c:spPr>
             <c:extLst>
               <c:ext xmlns:c16="http://schemas.microsoft.com/office/drawing/2014/chart" uri="{C3380CC4-5D6E-409C-BE32-E72D297353CC}">
-                <c16:uniqueId val="{00000003-7282-CF46-8ED7-62AD0FCCDF53}"/>
+                <c16:uniqueId val="{00000001-9339-3947-A15E-00F78FA941BD}"/>
               </c:ext>
             </c:extLst>
           </c:dPt>
@@ -797,7 +805,7 @@
             <c:bubble3D val="0"/>
             <c:spPr>
               <a:solidFill>
-                <a:srgbClr val="E0011D"/>
+                <a:srgbClr val="E00120"/>
               </a:solidFill>
               <a:ln>
                 <a:noFill/>
@@ -806,7 +814,7 @@
             </c:spPr>
             <c:extLst>
               <c:ext xmlns:c16="http://schemas.microsoft.com/office/drawing/2014/chart" uri="{C3380CC4-5D6E-409C-BE32-E72D297353CC}">
-                <c16:uniqueId val="{00000002-7282-CF46-8ED7-62AD0FCCDF53}"/>
+                <c16:uniqueId val="{00000003-9339-3947-A15E-00F78FA941BD}"/>
               </c:ext>
             </c:extLst>
           </c:dPt>
@@ -825,7 +833,7 @@
             </c:spPr>
             <c:extLst>
               <c:ext xmlns:c16="http://schemas.microsoft.com/office/drawing/2014/chart" uri="{C3380CC4-5D6E-409C-BE32-E72D297353CC}">
-                <c16:uniqueId val="{00000001-7282-CF46-8ED7-62AD0FCCDF53}"/>
+                <c16:uniqueId val="{00000005-9339-3947-A15E-00F78FA941BD}"/>
               </c:ext>
             </c:extLst>
           </c:dPt>
@@ -834,7 +842,7 @@
               <c:idx val="0"/>
               <c:spPr>
                 <a:solidFill>
-                  <a:schemeClr val="bg1"/>
+                  <a:schemeClr val="lt1"/>
                 </a:solidFill>
                 <a:ln>
                   <a:noFill/>
@@ -842,8 +850,8 @@
                 <a:effectLst/>
               </c:spPr>
               <c:txPr>
-                <a:bodyPr rot="0" spcFirstLastPara="1" vertOverflow="overflow" horzOverflow="overflow" vert="horz" wrap="square" lIns="38100" tIns="19050" rIns="38100" bIns="19050" anchor="ctr" anchorCtr="1">
-                  <a:noAutofit/>
+                <a:bodyPr rot="0" spcFirstLastPara="1" vertOverflow="ellipsis" vert="horz" wrap="square" lIns="38100" tIns="19050" rIns="38100" bIns="19050" anchor="ctr" anchorCtr="1">
+                  <a:spAutoFit/>
                 </a:bodyPr>
                 <a:lstStyle/>
                 <a:p>
@@ -863,7 +871,6 @@
                   <a:endParaRPr lang="en-HU"/>
                 </a:p>
               </c:txPr>
-              <c:dLblPos val="ctr"/>
               <c:showLegendKey val="0"/>
               <c:showVal val="1"/>
               <c:showCatName val="0"/>
@@ -871,32 +878,17 @@
               <c:showPercent val="0"/>
               <c:showBubbleSize val="0"/>
               <c:extLst>
-                <c:ext xmlns:c15="http://schemas.microsoft.com/office/drawing/2012/chart" uri="{CE6537A1-D6FC-4f65-9D91-7224C49458BB}">
-                  <c15:spPr xmlns:c15="http://schemas.microsoft.com/office/drawing/2012/chart">
-                    <a:prstGeom prst="rect">
-                      <a:avLst/>
-                    </a:prstGeom>
-                    <a:noFill/>
-                    <a:ln>
-                      <a:noFill/>
-                    </a:ln>
-                  </c15:spPr>
-                  <c15:layout>
-                    <c:manualLayout>
-                      <c:w val="3.7920876586206194E-2"/>
-                      <c:h val="0.20036882706314954"/>
-                    </c:manualLayout>
-                  </c15:layout>
-                </c:ext>
                 <c:ext xmlns:c16="http://schemas.microsoft.com/office/drawing/2014/chart" uri="{C3380CC4-5D6E-409C-BE32-E72D297353CC}">
-                  <c16:uniqueId val="{00000003-7282-CF46-8ED7-62AD0FCCDF53}"/>
+                  <c16:uniqueId val="{00000001-9339-3947-A15E-00F78FA941BD}"/>
                 </c:ext>
               </c:extLst>
             </c:dLbl>
             <c:dLbl>
               <c:idx val="1"/>
               <c:spPr>
-                <a:noFill/>
+                <a:solidFill>
+                  <a:srgbClr val="E00120"/>
+                </a:solidFill>
                 <a:ln>
                   <a:noFill/>
                 </a:ln>
@@ -929,14 +921,16 @@
               <c:showBubbleSize val="0"/>
               <c:extLst>
                 <c:ext xmlns:c16="http://schemas.microsoft.com/office/drawing/2014/chart" uri="{C3380CC4-5D6E-409C-BE32-E72D297353CC}">
-                  <c16:uniqueId val="{00000002-7282-CF46-8ED7-62AD0FCCDF53}"/>
+                  <c16:uniqueId val="{00000003-9339-3947-A15E-00F78FA941BD}"/>
                 </c:ext>
               </c:extLst>
             </c:dLbl>
             <c:dLbl>
               <c:idx val="2"/>
               <c:spPr>
-                <a:noFill/>
+                <a:solidFill>
+                  <a:srgbClr val="99001E"/>
+                </a:solidFill>
                 <a:ln>
                   <a:noFill/>
                 </a:ln>
@@ -969,7 +963,7 @@
               <c:showBubbleSize val="0"/>
               <c:extLst>
                 <c:ext xmlns:c16="http://schemas.microsoft.com/office/drawing/2014/chart" uri="{C3380CC4-5D6E-409C-BE32-E72D297353CC}">
-                  <c16:uniqueId val="{00000001-7282-CF46-8ED7-62AD0FCCDF53}"/>
+                  <c16:uniqueId val="{00000005-9339-3947-A15E-00F78FA941BD}"/>
                 </c:ext>
               </c:extLst>
             </c:dLbl>
@@ -1031,42 +1025,42 @@
           </c:dLbls>
           <c:cat>
             <c:strRef>
-              <c:f>'Net Financials'!$A$11:$A$13</c:f>
+              <c:f>Sheet1!$A$2:$A$4</c:f>
               <c:strCache>
                 <c:ptCount val="3"/>
                 <c:pt idx="0">
-                  <c:v>Q3 2024</c:v>
+                  <c:v>Q4 2024</c:v>
                 </c:pt>
                 <c:pt idx="1">
-                  <c:v>Q2 2025</c:v>
+                  <c:v>Q3 2025</c:v>
                 </c:pt>
                 <c:pt idx="2">
-                  <c:v>Q3 2025</c:v>
+                  <c:v>Q4 2025</c:v>
                 </c:pt>
               </c:strCache>
             </c:strRef>
           </c:cat>
           <c:val>
             <c:numRef>
-              <c:f>'Net Financials'!$B$11:$B$13</c:f>
+              <c:f>Sheet1!$B$2:$B$4</c:f>
               <c:numCache>
                 <c:formatCode>General</c:formatCode>
                 <c:ptCount val="3"/>
                 <c:pt idx="0">
-                  <c:v>341</c:v>
+                  <c:v>0</c:v>
                 </c:pt>
                 <c:pt idx="1">
-                  <c:v>413</c:v>
+                  <c:v>0</c:v>
                 </c:pt>
                 <c:pt idx="2">
-                  <c:v>404</c:v>
+                  <c:v>0</c:v>
                 </c:pt>
               </c:numCache>
             </c:numRef>
           </c:val>
           <c:extLst>
             <c:ext xmlns:c16="http://schemas.microsoft.com/office/drawing/2014/chart" uri="{C3380CC4-5D6E-409C-BE32-E72D297353CC}">
-              <c16:uniqueId val="{00000000-7282-CF46-8ED7-62AD0FCCDF53}"/>
+              <c16:uniqueId val="{00000006-9339-3947-A15E-00F78FA941BD}"/>
             </c:ext>
           </c:extLst>
         </c:ser>
@@ -1078,13 +1072,13 @@
           <c:showPercent val="0"/>
           <c:showBubbleSize val="0"/>
         </c:dLbls>
-        <c:gapWidth val="76"/>
+        <c:gapWidth val="75"/>
         <c:overlap val="100"/>
-        <c:axId val="1272050816"/>
-        <c:axId val="1272052608"/>
+        <c:axId val="1404788159"/>
+        <c:axId val="1404789951"/>
       </c:barChart>
       <c:catAx>
-        <c:axId val="1272050816"/>
+        <c:axId val="1404788159"/>
         <c:scaling>
           <c:orientation val="minMax"/>
         </c:scaling>
@@ -1105,7 +1099,7 @@
           <a:effectLst/>
         </c:spPr>
         <c:txPr>
-          <a:bodyPr rot="-60000000" spcFirstLastPara="1" vertOverflow="ellipsis" vert="horz" wrap="square" anchor="t" anchorCtr="0"/>
+          <a:bodyPr rot="-60000000" spcFirstLastPara="1" vertOverflow="ellipsis" vert="horz" wrap="square" anchor="ctr" anchorCtr="0"/>
           <a:lstStyle/>
           <a:p>
             <a:pPr>
@@ -1121,7 +1115,7 @@
             <a:endParaRPr lang="en-HU"/>
           </a:p>
         </c:txPr>
-        <c:crossAx val="1272052608"/>
+        <c:crossAx val="1404789951"/>
         <c:crosses val="autoZero"/>
         <c:auto val="1"/>
         <c:lblAlgn val="ctr"/>
@@ -1129,7 +1123,7 @@
         <c:noMultiLvlLbl val="0"/>
       </c:catAx>
       <c:valAx>
-        <c:axId val="1272052608"/>
+        <c:axId val="1404789951"/>
         <c:scaling>
           <c:orientation val="minMax"/>
         </c:scaling>
@@ -1139,7 +1133,7 @@
         <c:majorTickMark val="none"/>
         <c:minorTickMark val="none"/>
         <c:tickLblPos val="nextTo"/>
-        <c:crossAx val="1272050816"/>
+        <c:crossAx val="1404788159"/>
         <c:crosses val="autoZero"/>
         <c:crossBetween val="between"/>
       </c:valAx>
@@ -1188,7 +1182,7 @@
 <file path=ppt/charts/chart3.xml><?xml version="1.0" encoding="utf-8"?>
 <c:chartSpace xmlns:c="http://schemas.openxmlformats.org/drawingml/2006/chart" xmlns:a="http://schemas.openxmlformats.org/drawingml/2006/main" xmlns:r="http://schemas.openxmlformats.org/officeDocument/2006/relationships" xmlns:c16r2="http://schemas.microsoft.com/office/drawing/2015/06/chart">
   <c:date1904 val="0"/>
-  <c:lang val="hu-HU"/>
+  <c:lang val="en-GB"/>
   <c:roundedCorners val="0"/>
   <mc:AlternateContent xmlns:mc="http://schemas.openxmlformats.org/markup-compatibility/2006">
     <mc:Choice xmlns:c14="http://schemas.microsoft.com/office/drawing/2007/8/2/chart" Requires="c14">
@@ -1206,10 +1200,10 @@
           <c:layoutTarget val="inner"/>
           <c:xMode val="edge"/>
           <c:yMode val="edge"/>
-          <c:x val="2.1022009758305576E-2"/>
-          <c:y val="0.25918078834001845"/>
-          <c:w val="0.95795598048338881"/>
-          <c:h val="0.42183018370853015"/>
+          <c:x val="2.1043977091740444E-2"/>
+          <c:y val="0.22002044284429578"/>
+          <c:w val="0.95791204581651912"/>
+          <c:h val="0.43471440653541038"/>
         </c:manualLayout>
       </c:layout>
       <c:barChart>
@@ -1219,6 +1213,17 @@
         <c:ser>
           <c:idx val="0"/>
           <c:order val="0"/>
+          <c:tx>
+            <c:strRef>
+              <c:f>Sheet1!$B$1</c:f>
+              <c:strCache>
+                <c:ptCount val="1"/>
+                <c:pt idx="0">
+                  <c:v>Series 1</c:v>
+                </c:pt>
+              </c:strCache>
+            </c:strRef>
+          </c:tx>
           <c:spPr>
             <a:solidFill>
               <a:schemeClr val="accent1"/>
@@ -1246,7 +1251,7 @@
             </c:spPr>
             <c:extLst>
               <c:ext xmlns:c16="http://schemas.microsoft.com/office/drawing/2014/chart" uri="{C3380CC4-5D6E-409C-BE32-E72D297353CC}">
-                <c16:uniqueId val="{00000003-7282-CF46-8ED7-62AD0FCCDF53}"/>
+                <c16:uniqueId val="{00000001-9DAB-D24E-BED4-23E216F191C0}"/>
               </c:ext>
             </c:extLst>
           </c:dPt>
@@ -1256,7 +1261,7 @@
             <c:bubble3D val="0"/>
             <c:spPr>
               <a:solidFill>
-                <a:srgbClr val="E0011D"/>
+                <a:srgbClr val="E00120"/>
               </a:solidFill>
               <a:ln>
                 <a:noFill/>
@@ -1265,7 +1270,7 @@
             </c:spPr>
             <c:extLst>
               <c:ext xmlns:c16="http://schemas.microsoft.com/office/drawing/2014/chart" uri="{C3380CC4-5D6E-409C-BE32-E72D297353CC}">
-                <c16:uniqueId val="{00000002-7282-CF46-8ED7-62AD0FCCDF53}"/>
+                <c16:uniqueId val="{00000003-9DAB-D24E-BED4-23E216F191C0}"/>
               </c:ext>
             </c:extLst>
           </c:dPt>
@@ -1284,7 +1289,7 @@
             </c:spPr>
             <c:extLst>
               <c:ext xmlns:c16="http://schemas.microsoft.com/office/drawing/2014/chart" uri="{C3380CC4-5D6E-409C-BE32-E72D297353CC}">
-                <c16:uniqueId val="{00000001-7282-CF46-8ED7-62AD0FCCDF53}"/>
+                <c16:uniqueId val="{00000005-9DAB-D24E-BED4-23E216F191C0}"/>
               </c:ext>
             </c:extLst>
           </c:dPt>
@@ -1293,7 +1298,7 @@
               <c:idx val="0"/>
               <c:spPr>
                 <a:solidFill>
-                  <a:schemeClr val="bg1"/>
+                  <a:schemeClr val="lt1"/>
                 </a:solidFill>
                 <a:ln>
                   <a:noFill/>
@@ -1301,8 +1306,8 @@
                 <a:effectLst/>
               </c:spPr>
               <c:txPr>
-                <a:bodyPr rot="0" spcFirstLastPara="1" vertOverflow="overflow" horzOverflow="overflow" vert="horz" wrap="square" lIns="38100" tIns="19050" rIns="38100" bIns="19050" anchor="ctr" anchorCtr="1">
-                  <a:noAutofit/>
+                <a:bodyPr rot="0" spcFirstLastPara="1" vertOverflow="ellipsis" vert="horz" wrap="square" lIns="38100" tIns="19050" rIns="38100" bIns="19050" anchor="ctr" anchorCtr="1">
+                  <a:spAutoFit/>
                 </a:bodyPr>
                 <a:lstStyle/>
                 <a:p>
@@ -1322,7 +1327,6 @@
                   <a:endParaRPr lang="en-HU"/>
                 </a:p>
               </c:txPr>
-              <c:dLblPos val="ctr"/>
               <c:showLegendKey val="0"/>
               <c:showVal val="1"/>
               <c:showCatName val="0"/>
@@ -1330,32 +1334,17 @@
               <c:showPercent val="0"/>
               <c:showBubbleSize val="0"/>
               <c:extLst>
-                <c:ext xmlns:c15="http://schemas.microsoft.com/office/drawing/2012/chart" uri="{CE6537A1-D6FC-4f65-9D91-7224C49458BB}">
-                  <c15:spPr xmlns:c15="http://schemas.microsoft.com/office/drawing/2012/chart">
-                    <a:prstGeom prst="rect">
-                      <a:avLst/>
-                    </a:prstGeom>
-                    <a:noFill/>
-                    <a:ln>
-                      <a:noFill/>
-                    </a:ln>
-                  </c15:spPr>
-                  <c15:layout>
-                    <c:manualLayout>
-                      <c:w val="3.7920876586206194E-2"/>
-                      <c:h val="0.20036882706314954"/>
-                    </c:manualLayout>
-                  </c15:layout>
-                </c:ext>
                 <c:ext xmlns:c16="http://schemas.microsoft.com/office/drawing/2014/chart" uri="{C3380CC4-5D6E-409C-BE32-E72D297353CC}">
-                  <c16:uniqueId val="{00000003-7282-CF46-8ED7-62AD0FCCDF53}"/>
+                  <c16:uniqueId val="{00000001-9DAB-D24E-BED4-23E216F191C0}"/>
                 </c:ext>
               </c:extLst>
             </c:dLbl>
             <c:dLbl>
               <c:idx val="1"/>
               <c:spPr>
-                <a:noFill/>
+                <a:solidFill>
+                  <a:srgbClr val="E00120"/>
+                </a:solidFill>
                 <a:ln>
                   <a:noFill/>
                 </a:ln>
@@ -1388,7 +1377,7 @@
               <c:showBubbleSize val="0"/>
               <c:extLst>
                 <c:ext xmlns:c16="http://schemas.microsoft.com/office/drawing/2014/chart" uri="{C3380CC4-5D6E-409C-BE32-E72D297353CC}">
-                  <c16:uniqueId val="{00000002-7282-CF46-8ED7-62AD0FCCDF53}"/>
+                  <c16:uniqueId val="{00000003-9DAB-D24E-BED4-23E216F191C0}"/>
                 </c:ext>
               </c:extLst>
             </c:dLbl>
@@ -1430,7 +1419,7 @@
               <c:showBubbleSize val="0"/>
               <c:extLst>
                 <c:ext xmlns:c16="http://schemas.microsoft.com/office/drawing/2014/chart" uri="{C3380CC4-5D6E-409C-BE32-E72D297353CC}">
-                  <c16:uniqueId val="{00000001-7282-CF46-8ED7-62AD0FCCDF53}"/>
+                  <c16:uniqueId val="{00000005-9DAB-D24E-BED4-23E216F191C0}"/>
                 </c:ext>
               </c:extLst>
             </c:dLbl>
@@ -1492,24 +1481,24 @@
           </c:dLbls>
           <c:cat>
             <c:strRef>
-              <c:f>'Net Financials'!$A$17:$A$19</c:f>
+              <c:f>Sheet1!$A$2:$A$4</c:f>
               <c:strCache>
                 <c:ptCount val="3"/>
                 <c:pt idx="0">
-                  <c:v>Q3 2024</c:v>
+                  <c:v>Q4 2024</c:v>
                 </c:pt>
                 <c:pt idx="1">
-                  <c:v>Q2 2025</c:v>
+                  <c:v>Q3 2025</c:v>
                 </c:pt>
                 <c:pt idx="2">
-                  <c:v>Q3 2025</c:v>
+                  <c:v>Q4 2025</c:v>
                 </c:pt>
               </c:strCache>
             </c:strRef>
           </c:cat>
           <c:val>
             <c:numRef>
-              <c:f>'Net Financials'!$B$17:$B$19</c:f>
+              <c:f>Sheet1!$B$2:$B$4</c:f>
               <c:numCache>
                 <c:formatCode>General</c:formatCode>
                 <c:ptCount val="3"/>
@@ -1517,17 +1506,17 @@
                   <c:v>0</c:v>
                 </c:pt>
                 <c:pt idx="1">
-                  <c:v>-33</c:v>
+                  <c:v>0</c:v>
                 </c:pt>
                 <c:pt idx="2">
-                  <c:v>-6</c:v>
+                  <c:v>0</c:v>
                 </c:pt>
               </c:numCache>
             </c:numRef>
           </c:val>
           <c:extLst>
             <c:ext xmlns:c16="http://schemas.microsoft.com/office/drawing/2014/chart" uri="{C3380CC4-5D6E-409C-BE32-E72D297353CC}">
-              <c16:uniqueId val="{00000000-7282-CF46-8ED7-62AD0FCCDF53}"/>
+              <c16:uniqueId val="{00000006-9DAB-D24E-BED4-23E216F191C0}"/>
             </c:ext>
           </c:extLst>
         </c:ser>
@@ -1539,13 +1528,13 @@
           <c:showPercent val="0"/>
           <c:showBubbleSize val="0"/>
         </c:dLbls>
-        <c:gapWidth val="76"/>
+        <c:gapWidth val="75"/>
         <c:overlap val="100"/>
-        <c:axId val="1272050816"/>
-        <c:axId val="1272052608"/>
+        <c:axId val="1404788159"/>
+        <c:axId val="1404789951"/>
       </c:barChart>
       <c:catAx>
-        <c:axId val="1272050816"/>
+        <c:axId val="1404788159"/>
         <c:scaling>
           <c:orientation val="minMax"/>
         </c:scaling>
@@ -1566,7 +1555,7 @@
           <a:effectLst/>
         </c:spPr>
         <c:txPr>
-          <a:bodyPr rot="-60000000" spcFirstLastPara="1" vertOverflow="ellipsis" vert="horz" wrap="square" anchor="t" anchorCtr="0"/>
+          <a:bodyPr rot="-60000000" spcFirstLastPara="1" vertOverflow="ellipsis" vert="horz" wrap="square" anchor="ctr" anchorCtr="0"/>
           <a:lstStyle/>
           <a:p>
             <a:pPr>
@@ -1582,7 +1571,7 @@
             <a:endParaRPr lang="en-HU"/>
           </a:p>
         </c:txPr>
-        <c:crossAx val="1272052608"/>
+        <c:crossAx val="1404789951"/>
         <c:crosses val="autoZero"/>
         <c:auto val="1"/>
         <c:lblAlgn val="ctr"/>
@@ -1590,7 +1579,7 @@
         <c:noMultiLvlLbl val="0"/>
       </c:catAx>
       <c:valAx>
-        <c:axId val="1272052608"/>
+        <c:axId val="1404789951"/>
         <c:scaling>
           <c:orientation val="minMax"/>
         </c:scaling>
@@ -1600,7 +1589,7 @@
         <c:majorTickMark val="none"/>
         <c:minorTickMark val="none"/>
         <c:tickLblPos val="nextTo"/>
-        <c:crossAx val="1272050816"/>
+        <c:crossAx val="1404788159"/>
         <c:crosses val="autoZero"/>
         <c:crossBetween val="between"/>
       </c:valAx>
@@ -1649,7 +1638,7 @@
 <file path=ppt/charts/chart4.xml><?xml version="1.0" encoding="utf-8"?>
 <c:chartSpace xmlns:c="http://schemas.openxmlformats.org/drawingml/2006/chart" xmlns:a="http://schemas.openxmlformats.org/drawingml/2006/main" xmlns:r="http://schemas.openxmlformats.org/officeDocument/2006/relationships" xmlns:c16r2="http://schemas.microsoft.com/office/drawing/2015/06/chart">
   <c:date1904 val="0"/>
-  <c:lang val="hu-HU"/>
+  <c:lang val="en-GB"/>
   <c:roundedCorners val="0"/>
   <mc:AlternateContent xmlns:mc="http://schemas.openxmlformats.org/markup-compatibility/2006">
     <mc:Choice xmlns:c14="http://schemas.microsoft.com/office/drawing/2007/8/2/chart" Requires="c14">
@@ -1667,10 +1656,10 @@
           <c:layoutTarget val="inner"/>
           <c:xMode val="edge"/>
           <c:yMode val="edge"/>
-          <c:x val="2.1022009758305576E-2"/>
-          <c:y val="0.25918078834001845"/>
-          <c:w val="0.95795598048338881"/>
-          <c:h val="0.42183018370853015"/>
+          <c:x val="2.1043977091740444E-2"/>
+          <c:y val="0.22002044284429578"/>
+          <c:w val="0.95791204581651912"/>
+          <c:h val="0.43471440653541038"/>
         </c:manualLayout>
       </c:layout>
       <c:barChart>
@@ -1680,6 +1669,17 @@
         <c:ser>
           <c:idx val="0"/>
           <c:order val="0"/>
+          <c:tx>
+            <c:strRef>
+              <c:f>Sheet1!$B$1</c:f>
+              <c:strCache>
+                <c:ptCount val="1"/>
+                <c:pt idx="0">
+                  <c:v>Series 1</c:v>
+                </c:pt>
+              </c:strCache>
+            </c:strRef>
+          </c:tx>
           <c:spPr>
             <a:solidFill>
               <a:schemeClr val="accent1"/>
@@ -1707,7 +1707,7 @@
             </c:spPr>
             <c:extLst>
               <c:ext xmlns:c16="http://schemas.microsoft.com/office/drawing/2014/chart" uri="{C3380CC4-5D6E-409C-BE32-E72D297353CC}">
-                <c16:uniqueId val="{00000003-7282-CF46-8ED7-62AD0FCCDF53}"/>
+                <c16:uniqueId val="{00000001-CED5-CE45-A284-9FE284AF65F6}"/>
               </c:ext>
             </c:extLst>
           </c:dPt>
@@ -1717,7 +1717,7 @@
             <c:bubble3D val="0"/>
             <c:spPr>
               <a:solidFill>
-                <a:srgbClr val="E0011D"/>
+                <a:srgbClr val="E00120"/>
               </a:solidFill>
               <a:ln>
                 <a:noFill/>
@@ -1726,7 +1726,7 @@
             </c:spPr>
             <c:extLst>
               <c:ext xmlns:c16="http://schemas.microsoft.com/office/drawing/2014/chart" uri="{C3380CC4-5D6E-409C-BE32-E72D297353CC}">
-                <c16:uniqueId val="{00000002-7282-CF46-8ED7-62AD0FCCDF53}"/>
+                <c16:uniqueId val="{00000003-CED5-CE45-A284-9FE284AF65F6}"/>
               </c:ext>
             </c:extLst>
           </c:dPt>
@@ -1745,7 +1745,7 @@
             </c:spPr>
             <c:extLst>
               <c:ext xmlns:c16="http://schemas.microsoft.com/office/drawing/2014/chart" uri="{C3380CC4-5D6E-409C-BE32-E72D297353CC}">
-                <c16:uniqueId val="{00000001-7282-CF46-8ED7-62AD0FCCDF53}"/>
+                <c16:uniqueId val="{00000005-CED5-CE45-A284-9FE284AF65F6}"/>
               </c:ext>
             </c:extLst>
           </c:dPt>
@@ -1754,7 +1754,7 @@
               <c:idx val="0"/>
               <c:spPr>
                 <a:solidFill>
-                  <a:schemeClr val="bg1"/>
+                  <a:schemeClr val="lt1"/>
                 </a:solidFill>
                 <a:ln>
                   <a:noFill/>
@@ -1762,8 +1762,8 @@
                 <a:effectLst/>
               </c:spPr>
               <c:txPr>
-                <a:bodyPr rot="0" spcFirstLastPara="1" vertOverflow="overflow" horzOverflow="overflow" vert="horz" wrap="square" lIns="38100" tIns="19050" rIns="38100" bIns="19050" anchor="ctr" anchorCtr="1">
-                  <a:noAutofit/>
+                <a:bodyPr rot="0" spcFirstLastPara="1" vertOverflow="ellipsis" vert="horz" wrap="square" lIns="38100" tIns="19050" rIns="38100" bIns="19050" anchor="ctr" anchorCtr="1">
+                  <a:spAutoFit/>
                 </a:bodyPr>
                 <a:lstStyle/>
                 <a:p>
@@ -1783,7 +1783,6 @@
                   <a:endParaRPr lang="en-HU"/>
                 </a:p>
               </c:txPr>
-              <c:dLblPos val="ctr"/>
               <c:showLegendKey val="0"/>
               <c:showVal val="1"/>
               <c:showCatName val="0"/>
@@ -1791,32 +1790,17 @@
               <c:showPercent val="0"/>
               <c:showBubbleSize val="0"/>
               <c:extLst>
-                <c:ext xmlns:c15="http://schemas.microsoft.com/office/drawing/2012/chart" uri="{CE6537A1-D6FC-4f65-9D91-7224C49458BB}">
-                  <c15:spPr xmlns:c15="http://schemas.microsoft.com/office/drawing/2012/chart">
-                    <a:prstGeom prst="rect">
-                      <a:avLst/>
-                    </a:prstGeom>
-                    <a:noFill/>
-                    <a:ln>
-                      <a:noFill/>
-                    </a:ln>
-                  </c15:spPr>
-                  <c15:layout>
-                    <c:manualLayout>
-                      <c:w val="3.7920876586206194E-2"/>
-                      <c:h val="0.20036882706314954"/>
-                    </c:manualLayout>
-                  </c15:layout>
-                </c:ext>
                 <c:ext xmlns:c16="http://schemas.microsoft.com/office/drawing/2014/chart" uri="{C3380CC4-5D6E-409C-BE32-E72D297353CC}">
-                  <c16:uniqueId val="{00000003-7282-CF46-8ED7-62AD0FCCDF53}"/>
+                  <c16:uniqueId val="{00000001-CED5-CE45-A284-9FE284AF65F6}"/>
                 </c:ext>
               </c:extLst>
             </c:dLbl>
             <c:dLbl>
               <c:idx val="1"/>
               <c:spPr>
-                <a:noFill/>
+                <a:solidFill>
+                  <a:srgbClr val="E00120"/>
+                </a:solidFill>
                 <a:ln>
                   <a:noFill/>
                 </a:ln>
@@ -1849,7 +1833,7 @@
               <c:showBubbleSize val="0"/>
               <c:extLst>
                 <c:ext xmlns:c16="http://schemas.microsoft.com/office/drawing/2014/chart" uri="{C3380CC4-5D6E-409C-BE32-E72D297353CC}">
-                  <c16:uniqueId val="{00000002-7282-CF46-8ED7-62AD0FCCDF53}"/>
+                  <c16:uniqueId val="{00000003-CED5-CE45-A284-9FE284AF65F6}"/>
                 </c:ext>
               </c:extLst>
             </c:dLbl>
@@ -1891,7 +1875,7 @@
               <c:showBubbleSize val="0"/>
               <c:extLst>
                 <c:ext xmlns:c16="http://schemas.microsoft.com/office/drawing/2014/chart" uri="{C3380CC4-5D6E-409C-BE32-E72D297353CC}">
-                  <c16:uniqueId val="{00000001-7282-CF46-8ED7-62AD0FCCDF53}"/>
+                  <c16:uniqueId val="{00000005-CED5-CE45-A284-9FE284AF65F6}"/>
                 </c:ext>
               </c:extLst>
             </c:dLbl>
@@ -1953,42 +1937,42 @@
           </c:dLbls>
           <c:cat>
             <c:strRef>
-              <c:f>'Net Financials'!$A$23:$A$25</c:f>
+              <c:f>Sheet1!$A$2:$A$4</c:f>
               <c:strCache>
                 <c:ptCount val="3"/>
                 <c:pt idx="0">
-                  <c:v>Q3 2024</c:v>
+                  <c:v>Q4 2024</c:v>
                 </c:pt>
                 <c:pt idx="1">
-                  <c:v>Q2 2025</c:v>
+                  <c:v>Q3 2025</c:v>
                 </c:pt>
                 <c:pt idx="2">
-                  <c:v>Q3 2025</c:v>
+                  <c:v>Q4 2025</c:v>
                 </c:pt>
               </c:strCache>
             </c:strRef>
           </c:cat>
           <c:val>
             <c:numRef>
-              <c:f>'Net Financials'!$B$23:$B$25</c:f>
+              <c:f>Sheet1!$B$2:$B$4</c:f>
               <c:numCache>
                 <c:formatCode>General</c:formatCode>
                 <c:ptCount val="3"/>
                 <c:pt idx="0">
-                  <c:v>15</c:v>
+                  <c:v>0</c:v>
                 </c:pt>
                 <c:pt idx="1">
-                  <c:v>5</c:v>
+                  <c:v>0</c:v>
                 </c:pt>
                 <c:pt idx="2">
-                  <c:v>17</c:v>
+                  <c:v>0</c:v>
                 </c:pt>
               </c:numCache>
             </c:numRef>
           </c:val>
           <c:extLst>
             <c:ext xmlns:c16="http://schemas.microsoft.com/office/drawing/2014/chart" uri="{C3380CC4-5D6E-409C-BE32-E72D297353CC}">
-              <c16:uniqueId val="{00000000-7282-CF46-8ED7-62AD0FCCDF53}"/>
+              <c16:uniqueId val="{00000006-CED5-CE45-A284-9FE284AF65F6}"/>
             </c:ext>
           </c:extLst>
         </c:ser>
@@ -2000,13 +1984,13 @@
           <c:showPercent val="0"/>
           <c:showBubbleSize val="0"/>
         </c:dLbls>
-        <c:gapWidth val="76"/>
+        <c:gapWidth val="75"/>
         <c:overlap val="100"/>
-        <c:axId val="1272050816"/>
-        <c:axId val="1272052608"/>
+        <c:axId val="1404788159"/>
+        <c:axId val="1404789951"/>
       </c:barChart>
       <c:catAx>
-        <c:axId val="1272050816"/>
+        <c:axId val="1404788159"/>
         <c:scaling>
           <c:orientation val="minMax"/>
         </c:scaling>
@@ -2027,7 +2011,7 @@
           <a:effectLst/>
         </c:spPr>
         <c:txPr>
-          <a:bodyPr rot="-60000000" spcFirstLastPara="1" vertOverflow="ellipsis" vert="horz" wrap="square" anchor="t" anchorCtr="0"/>
+          <a:bodyPr rot="-60000000" spcFirstLastPara="1" vertOverflow="ellipsis" vert="horz" wrap="square" anchor="ctr" anchorCtr="0"/>
           <a:lstStyle/>
           <a:p>
             <a:pPr>
@@ -2043,7 +2027,7 @@
             <a:endParaRPr lang="en-HU"/>
           </a:p>
         </c:txPr>
-        <c:crossAx val="1272052608"/>
+        <c:crossAx val="1404789951"/>
         <c:crosses val="autoZero"/>
         <c:auto val="1"/>
         <c:lblAlgn val="ctr"/>
@@ -2051,7 +2035,7 @@
         <c:noMultiLvlLbl val="0"/>
       </c:catAx>
       <c:valAx>
-        <c:axId val="1272052608"/>
+        <c:axId val="1404789951"/>
         <c:scaling>
           <c:orientation val="minMax"/>
         </c:scaling>
@@ -2061,7 +2045,7 @@
         <c:majorTickMark val="none"/>
         <c:minorTickMark val="none"/>
         <c:tickLblPos val="nextTo"/>
-        <c:crossAx val="1272050816"/>
+        <c:crossAx val="1404788159"/>
         <c:crosses val="autoZero"/>
         <c:crossBetween val="between"/>
       </c:valAx>
@@ -2110,7 +2094,7 @@
 <file path=ppt/charts/chart5.xml><?xml version="1.0" encoding="utf-8"?>
 <c:chartSpace xmlns:c="http://schemas.openxmlformats.org/drawingml/2006/chart" xmlns:a="http://schemas.openxmlformats.org/drawingml/2006/main" xmlns:r="http://schemas.openxmlformats.org/officeDocument/2006/relationships" xmlns:c16r2="http://schemas.microsoft.com/office/drawing/2015/06/chart">
   <c:date1904 val="0"/>
-  <c:lang val="hu-HU"/>
+  <c:lang val="en-GB"/>
   <c:roundedCorners val="0"/>
   <mc:AlternateContent xmlns:mc="http://schemas.openxmlformats.org/markup-compatibility/2006">
     <mc:Choice xmlns:c14="http://schemas.microsoft.com/office/drawing/2007/8/2/chart" Requires="c14">
@@ -2128,10 +2112,10 @@
           <c:layoutTarget val="inner"/>
           <c:xMode val="edge"/>
           <c:yMode val="edge"/>
-          <c:x val="2.1022009758305576E-2"/>
-          <c:y val="0.25918078834001845"/>
-          <c:w val="0.95795598048338881"/>
-          <c:h val="0.42183018370853015"/>
+          <c:x val="2.1043977091740444E-2"/>
+          <c:y val="0.22002044284429578"/>
+          <c:w val="0.95791204581651912"/>
+          <c:h val="0.43471440653541038"/>
         </c:manualLayout>
       </c:layout>
       <c:barChart>
@@ -2141,6 +2125,17 @@
         <c:ser>
           <c:idx val="0"/>
           <c:order val="0"/>
+          <c:tx>
+            <c:strRef>
+              <c:f>Sheet1!$B$1</c:f>
+              <c:strCache>
+                <c:ptCount val="1"/>
+                <c:pt idx="0">
+                  <c:v>Series 1</c:v>
+                </c:pt>
+              </c:strCache>
+            </c:strRef>
+          </c:tx>
           <c:spPr>
             <a:solidFill>
               <a:schemeClr val="accent1"/>
@@ -2168,7 +2163,7 @@
             </c:spPr>
             <c:extLst>
               <c:ext xmlns:c16="http://schemas.microsoft.com/office/drawing/2014/chart" uri="{C3380CC4-5D6E-409C-BE32-E72D297353CC}">
-                <c16:uniqueId val="{00000003-7282-CF46-8ED7-62AD0FCCDF53}"/>
+                <c16:uniqueId val="{00000001-70B6-3B4B-8524-0AB6665CD5A0}"/>
               </c:ext>
             </c:extLst>
           </c:dPt>
@@ -2178,7 +2173,7 @@
             <c:bubble3D val="0"/>
             <c:spPr>
               <a:solidFill>
-                <a:srgbClr val="E0011D"/>
+                <a:srgbClr val="E00120"/>
               </a:solidFill>
               <a:ln>
                 <a:noFill/>
@@ -2187,7 +2182,7 @@
             </c:spPr>
             <c:extLst>
               <c:ext xmlns:c16="http://schemas.microsoft.com/office/drawing/2014/chart" uri="{C3380CC4-5D6E-409C-BE32-E72D297353CC}">
-                <c16:uniqueId val="{00000002-7282-CF46-8ED7-62AD0FCCDF53}"/>
+                <c16:uniqueId val="{00000003-70B6-3B4B-8524-0AB6665CD5A0}"/>
               </c:ext>
             </c:extLst>
           </c:dPt>
@@ -2206,7 +2201,7 @@
             </c:spPr>
             <c:extLst>
               <c:ext xmlns:c16="http://schemas.microsoft.com/office/drawing/2014/chart" uri="{C3380CC4-5D6E-409C-BE32-E72D297353CC}">
-                <c16:uniqueId val="{00000001-7282-CF46-8ED7-62AD0FCCDF53}"/>
+                <c16:uniqueId val="{00000005-70B6-3B4B-8524-0AB6665CD5A0}"/>
               </c:ext>
             </c:extLst>
           </c:dPt>
@@ -2215,7 +2210,7 @@
               <c:idx val="0"/>
               <c:spPr>
                 <a:solidFill>
-                  <a:schemeClr val="bg1"/>
+                  <a:schemeClr val="lt1"/>
                 </a:solidFill>
                 <a:ln>
                   <a:noFill/>
@@ -2223,8 +2218,8 @@
                 <a:effectLst/>
               </c:spPr>
               <c:txPr>
-                <a:bodyPr rot="0" spcFirstLastPara="1" vertOverflow="overflow" horzOverflow="overflow" vert="horz" wrap="square" lIns="38100" tIns="19050" rIns="38100" bIns="19050" anchor="ctr" anchorCtr="1">
-                  <a:noAutofit/>
+                <a:bodyPr rot="0" spcFirstLastPara="1" vertOverflow="ellipsis" vert="horz" wrap="square" lIns="38100" tIns="19050" rIns="38100" bIns="19050" anchor="ctr" anchorCtr="1">
+                  <a:spAutoFit/>
                 </a:bodyPr>
                 <a:lstStyle/>
                 <a:p>
@@ -2244,7 +2239,6 @@
                   <a:endParaRPr lang="en-HU"/>
                 </a:p>
               </c:txPr>
-              <c:dLblPos val="ctr"/>
               <c:showLegendKey val="0"/>
               <c:showVal val="1"/>
               <c:showCatName val="0"/>
@@ -2252,32 +2246,17 @@
               <c:showPercent val="0"/>
               <c:showBubbleSize val="0"/>
               <c:extLst>
-                <c:ext xmlns:c15="http://schemas.microsoft.com/office/drawing/2012/chart" uri="{CE6537A1-D6FC-4f65-9D91-7224C49458BB}">
-                  <c15:spPr xmlns:c15="http://schemas.microsoft.com/office/drawing/2012/chart">
-                    <a:prstGeom prst="rect">
-                      <a:avLst/>
-                    </a:prstGeom>
-                    <a:noFill/>
-                    <a:ln>
-                      <a:noFill/>
-                    </a:ln>
-                  </c15:spPr>
-                  <c15:layout>
-                    <c:manualLayout>
-                      <c:w val="3.7920876586206194E-2"/>
-                      <c:h val="0.20036882706314954"/>
-                    </c:manualLayout>
-                  </c15:layout>
-                </c:ext>
                 <c:ext xmlns:c16="http://schemas.microsoft.com/office/drawing/2014/chart" uri="{C3380CC4-5D6E-409C-BE32-E72D297353CC}">
-                  <c16:uniqueId val="{00000003-7282-CF46-8ED7-62AD0FCCDF53}"/>
+                  <c16:uniqueId val="{00000001-70B6-3B4B-8524-0AB6665CD5A0}"/>
                 </c:ext>
               </c:extLst>
             </c:dLbl>
             <c:dLbl>
               <c:idx val="1"/>
               <c:spPr>
-                <a:noFill/>
+                <a:solidFill>
+                  <a:srgbClr val="E00120"/>
+                </a:solidFill>
                 <a:ln>
                   <a:noFill/>
                 </a:ln>
@@ -2310,7 +2289,7 @@
               <c:showBubbleSize val="0"/>
               <c:extLst>
                 <c:ext xmlns:c16="http://schemas.microsoft.com/office/drawing/2014/chart" uri="{C3380CC4-5D6E-409C-BE32-E72D297353CC}">
-                  <c16:uniqueId val="{00000002-7282-CF46-8ED7-62AD0FCCDF53}"/>
+                  <c16:uniqueId val="{00000003-70B6-3B4B-8524-0AB6665CD5A0}"/>
                 </c:ext>
               </c:extLst>
             </c:dLbl>
@@ -2352,7 +2331,7 @@
               <c:showBubbleSize val="0"/>
               <c:extLst>
                 <c:ext xmlns:c16="http://schemas.microsoft.com/office/drawing/2014/chart" uri="{C3380CC4-5D6E-409C-BE32-E72D297353CC}">
-                  <c16:uniqueId val="{00000001-7282-CF46-8ED7-62AD0FCCDF53}"/>
+                  <c16:uniqueId val="{00000005-70B6-3B4B-8524-0AB6665CD5A0}"/>
                 </c:ext>
               </c:extLst>
             </c:dLbl>
@@ -2414,42 +2393,42 @@
           </c:dLbls>
           <c:cat>
             <c:strRef>
-              <c:f>'Net Financials'!$A$29:$A$31</c:f>
+              <c:f>Sheet1!$A$2:$A$4</c:f>
               <c:strCache>
                 <c:ptCount val="3"/>
                 <c:pt idx="0">
-                  <c:v>Q3 2024</c:v>
+                  <c:v>Q4 2024</c:v>
                 </c:pt>
                 <c:pt idx="1">
-                  <c:v>Q2 2025</c:v>
+                  <c:v>Q3 2025</c:v>
                 </c:pt>
                 <c:pt idx="2">
-                  <c:v>Q3 2025</c:v>
+                  <c:v>Q4 2025</c:v>
                 </c:pt>
               </c:strCache>
             </c:strRef>
           </c:cat>
           <c:val>
             <c:numRef>
-              <c:f>'Net Financials'!$B$29:$B$31</c:f>
+              <c:f>Sheet1!$B$2:$B$4</c:f>
               <c:numCache>
                 <c:formatCode>General</c:formatCode>
                 <c:ptCount val="3"/>
                 <c:pt idx="0">
-                  <c:v>120</c:v>
+                  <c:v>0</c:v>
                 </c:pt>
                 <c:pt idx="1">
-                  <c:v>127</c:v>
+                  <c:v>0</c:v>
                 </c:pt>
                 <c:pt idx="2">
-                  <c:v>164</c:v>
+                  <c:v>0</c:v>
                 </c:pt>
               </c:numCache>
             </c:numRef>
           </c:val>
           <c:extLst>
             <c:ext xmlns:c16="http://schemas.microsoft.com/office/drawing/2014/chart" uri="{C3380CC4-5D6E-409C-BE32-E72D297353CC}">
-              <c16:uniqueId val="{00000000-7282-CF46-8ED7-62AD0FCCDF53}"/>
+              <c16:uniqueId val="{00000006-70B6-3B4B-8524-0AB6665CD5A0}"/>
             </c:ext>
           </c:extLst>
         </c:ser>
@@ -2461,13 +2440,13 @@
           <c:showPercent val="0"/>
           <c:showBubbleSize val="0"/>
         </c:dLbls>
-        <c:gapWidth val="76"/>
+        <c:gapWidth val="75"/>
         <c:overlap val="100"/>
-        <c:axId val="1272050816"/>
-        <c:axId val="1272052608"/>
+        <c:axId val="1404788159"/>
+        <c:axId val="1404789951"/>
       </c:barChart>
       <c:catAx>
-        <c:axId val="1272050816"/>
+        <c:axId val="1404788159"/>
         <c:scaling>
           <c:orientation val="minMax"/>
         </c:scaling>
@@ -2488,7 +2467,7 @@
           <a:effectLst/>
         </c:spPr>
         <c:txPr>
-          <a:bodyPr rot="-60000000" spcFirstLastPara="1" vertOverflow="ellipsis" vert="horz" wrap="square" anchor="t" anchorCtr="0"/>
+          <a:bodyPr rot="-60000000" spcFirstLastPara="1" vertOverflow="ellipsis" vert="horz" wrap="square" anchor="ctr" anchorCtr="0"/>
           <a:lstStyle/>
           <a:p>
             <a:pPr>
@@ -2504,7 +2483,7 @@
             <a:endParaRPr lang="en-HU"/>
           </a:p>
         </c:txPr>
-        <c:crossAx val="1272052608"/>
+        <c:crossAx val="1404789951"/>
         <c:crosses val="autoZero"/>
         <c:auto val="1"/>
         <c:lblAlgn val="ctr"/>
@@ -2512,7 +2491,7 @@
         <c:noMultiLvlLbl val="0"/>
       </c:catAx>
       <c:valAx>
-        <c:axId val="1272052608"/>
+        <c:axId val="1404789951"/>
         <c:scaling>
           <c:orientation val="minMax"/>
         </c:scaling>
@@ -2522,7 +2501,7 @@
         <c:majorTickMark val="none"/>
         <c:minorTickMark val="none"/>
         <c:tickLblPos val="nextTo"/>
-        <c:crossAx val="1272050816"/>
+        <c:crossAx val="1404788159"/>
         <c:crosses val="autoZero"/>
         <c:crossBetween val="between"/>
       </c:valAx>
@@ -2571,7 +2550,7 @@
 <file path=ppt/charts/chart6.xml><?xml version="1.0" encoding="utf-8"?>
 <c:chartSpace xmlns:c="http://schemas.openxmlformats.org/drawingml/2006/chart" xmlns:a="http://schemas.openxmlformats.org/drawingml/2006/main" xmlns:r="http://schemas.openxmlformats.org/officeDocument/2006/relationships" xmlns:c16r2="http://schemas.microsoft.com/office/drawing/2015/06/chart">
   <c:date1904 val="0"/>
-  <c:lang val="hu-HU"/>
+  <c:lang val="en-GB"/>
   <c:roundedCorners val="1"/>
   <c:style val="2"/>
   <c:chart>
@@ -3035,7 +3014,7 @@
 <file path=ppt/charts/chart7.xml><?xml version="1.0" encoding="utf-8"?>
 <c:chartSpace xmlns:c="http://schemas.openxmlformats.org/drawingml/2006/chart" xmlns:a="http://schemas.openxmlformats.org/drawingml/2006/main" xmlns:r="http://schemas.openxmlformats.org/officeDocument/2006/relationships" xmlns:c16r2="http://schemas.microsoft.com/office/drawing/2015/06/chart">
   <c:date1904 val="0"/>
-  <c:lang val="hu-HU"/>
+  <c:lang val="en-GB"/>
   <c:roundedCorners val="1"/>
   <c:style val="2"/>
   <c:chart>
@@ -3668,7 +3647,13 @@
             </cx:spPr>
           </cx:dataPt>
           <cx:dataLabels pos="ctr">
+            <cx:numFmt formatCode="# ##0;# ##0" sourceLinked="0"/>
             <cx:visibility seriesName="0" categoryName="0" value="1"/>
+            <cx:dataLabel idx="0">
+              <cx:spPr>
+                <a:noFill/>
+              </cx:spPr>
+            </cx:dataLabel>
             <cx:dataLabel idx="3">
               <cx:spPr>
                 <a:solidFill>
@@ -3693,7 +3678,7 @@
                       </a:solidFill>
                       <a:latin typeface="Arial"/>
                     </a:rPr>
-                    <a:t>0</a:t>
+                    <a:t> 0</a:t>
                   </a:r>
                 </a:p>
               </cx:txPr>
@@ -3723,7 +3708,7 @@
                       </a:solidFill>
                       <a:latin typeface="Arial"/>
                     </a:rPr>
-                    <a:t>0</a:t>
+                    <a:t> 0</a:t>
                   </a:r>
                 </a:p>
               </cx:txPr>
@@ -3753,7 +3738,7 @@
                       </a:solidFill>
                       <a:latin typeface="Arial"/>
                     </a:rPr>
-                    <a:t>0</a:t>
+                    <a:t> 0</a:t>
                   </a:r>
                 </a:p>
               </cx:txPr>
@@ -3783,7 +3768,7 @@
                       </a:solidFill>
                       <a:latin typeface="Arial"/>
                     </a:rPr>
-                    <a:t>0</a:t>
+                    <a:t> 0</a:t>
                   </a:r>
                 </a:p>
               </cx:txPr>
@@ -3854,7 +3839,7 @@
     <cx:externalData r:id="rId1" cx:autoUpdate="0"/>
     <cx:data id="0">
       <cx:strDim type="cat">
-        <cx:f>'Operating Cash Flow'!$A$5:$A$12</cx:f>
+        <cx:f>Sheet1!$A$2:$A$9</cx:f>
         <cx:lvl ptCount="8">
           <cx:pt idx="0">Profit before tax
 Cont. Operation</cx:pt>
@@ -3869,16 +3854,16 @@
         </cx:lvl>
       </cx:strDim>
       <cx:numDim type="val">
-        <cx:f>'Operating Cash Flow'!$B$5:$B$12</cx:f>
-        <cx:lvl ptCount="8" formatCode="General">
-          <cx:pt idx="0">1285</cx:pt>
-          <cx:pt idx="1">1154</cx:pt>
-          <cx:pt idx="2">-487</cx:pt>
-          <cx:pt idx="3">-141</cx:pt>
-          <cx:pt idx="4">1811</cx:pt>
-          <cx:pt idx="5">366</cx:pt>
-          <cx:pt idx="6">2177</cx:pt>
-          <cx:pt idx="7">840</cx:pt>
+        <cx:f>Sheet1!$B$2:$B$9</cx:f>
+        <cx:lvl ptCount="8" formatCode="Normál">
+          <cx:pt idx="0">0</cx:pt>
+          <cx:pt idx="1">0</cx:pt>
+          <cx:pt idx="2">0</cx:pt>
+          <cx:pt idx="3">0</cx:pt>
+          <cx:pt idx="4">0</cx:pt>
+          <cx:pt idx="5">0</cx:pt>
+          <cx:pt idx="6">0</cx:pt>
+          <cx:pt idx="7">0</cx:pt>
         </cx:lvl>
       </cx:numDim>
     </cx:data>
@@ -3886,21 +3871,18 @@
   <cx:chart>
     <cx:plotArea>
       <cx:plotAreaRegion>
-        <cx:series layoutId="waterfall" uniqueId="{77DE77FB-845C-F44D-913A-C659BDC6CEA7}">
-          <cx:tx>
-            <cx:txData>
-              <cx:f>'Operating Cash Flow'!$B$4</cx:f>
-              <cx:v>Value (USD mn)</cx:v>
-            </cx:txData>
-          </cx:tx>
+        <cx:series layoutId="waterfall" uniqueId="{8B6CBFBA-F593-7C4F-9ED3-2871758CCE76}">
           <cx:spPr>
+            <a:solidFill>
+              <a:srgbClr val="E00120"/>
+            </a:solidFill>
             <a:ln w="12700">
               <a:solidFill>
                 <a:srgbClr val="000000">
                   <a:alpha val="0"/>
                 </a:srgbClr>
               </a:solidFill>
-              <a:prstDash val="dash"/>
+              <a:prstDash val="lgDash"/>
             </a:ln>
           </cx:spPr>
           <cx:dataPt idx="0">
@@ -3924,31 +3906,17 @@
               </a:solidFill>
             </cx:spPr>
           </cx:dataPt>
-          <cx:dataPt idx="3">
-            <cx:spPr>
-              <a:solidFill>
-                <a:srgbClr val="E00120"/>
-              </a:solidFill>
-            </cx:spPr>
-          </cx:dataPt>
           <cx:dataPt idx="4">
             <cx:spPr>
               <a:solidFill>
-                <a:srgbClr val="99001E"/>
-              </a:solidFill>
-            </cx:spPr>
-          </cx:dataPt>
-          <cx:dataPt idx="5">
-            <cx:spPr>
-              <a:solidFill>
-                <a:srgbClr val="E00120"/>
+                <a:srgbClr val="C00000"/>
               </a:solidFill>
             </cx:spPr>
           </cx:dataPt>
           <cx:dataPt idx="6">
             <cx:spPr>
               <a:solidFill>
-                <a:srgbClr val="99001E"/>
+                <a:srgbClr val="C00000"/>
               </a:solidFill>
             </cx:spPr>
           </cx:dataPt>
@@ -3959,7 +3927,7 @@
               </a:solidFill>
             </cx:spPr>
           </cx:dataPt>
-          <cx:dataLabels>
+          <cx:dataLabels pos="ctr">
             <cx:numFmt formatCode="# ##0;# ##0" sourceLinked="0"/>
             <cx:txPr>
               <a:bodyPr spcFirstLastPara="1" vertOverflow="ellipsis" horzOverflow="overflow" wrap="square" lIns="0" tIns="0" rIns="0" bIns="0" anchor="ctr" anchorCtr="1"/>
@@ -3968,19 +3936,20 @@
                 <a:pPr algn="ctr" rtl="0">
                   <a:defRPr sz="1000" b="1">
                     <a:solidFill>
-                      <a:schemeClr val="tx1"/>
+                      <a:schemeClr val="bg1"/>
                     </a:solidFill>
                   </a:defRPr>
                 </a:pPr>
-                <a:endParaRPr lang="en-GB" sz="1000" b="1" i="0" u="none" strike="noStrike" baseline="0">
+                <a:endParaRPr lang="en-US" sz="1000" b="1" i="0" u="none" strike="noStrike" baseline="0">
                   <a:solidFill>
-                    <a:schemeClr val="tx1"/>
+                    <a:schemeClr val="bg1"/>
                   </a:solidFill>
                   <a:latin typeface="Arial"/>
                 </a:endParaRPr>
               </a:p>
             </cx:txPr>
-            <cx:dataLabel idx="1" pos="ctr">
+            <cx:visibility seriesName="0" categoryName="0" value="1"/>
+            <cx:dataLabel idx="0" pos="outEnd">
               <cx:txPr>
                 <a:bodyPr spcFirstLastPara="1" vertOverflow="ellipsis" horzOverflow="overflow" wrap="square" lIns="0" tIns="0" rIns="0" bIns="0" anchor="ctr" anchorCtr="1"/>
                 <a:lstStyle/>
@@ -3988,24 +3957,30 @@
                   <a:pPr algn="ctr" rtl="0">
                     <a:defRPr>
                       <a:solidFill>
-                        <a:schemeClr val="bg1"/>
+                        <a:schemeClr val="tx1"/>
                       </a:solidFill>
                     </a:defRPr>
                   </a:pPr>
                   <a:r>
-                    <a:rPr lang="en-GB" sz="1000" b="1" i="0" u="none" strike="noStrike" baseline="0">
+                    <a:rPr lang="en-US" sz="1000" b="1" i="0" u="none" strike="noStrike" baseline="0">
                       <a:solidFill>
-                        <a:schemeClr val="bg1"/>
+                        <a:schemeClr val="tx1"/>
                       </a:solidFill>
                       <a:latin typeface="Arial"/>
                     </a:rPr>
-                    <a:t>1 154</a:t>
+                    <a:t> 0</a:t>
                   </a:r>
                 </a:p>
               </cx:txPr>
             </cx:dataLabel>
-            <cx:dataLabel idx="2" pos="ctr">
-              <cx:numFmt formatCode="# ##0;# ##0" sourceLinked="0"/>
+            <cx:dataLabel idx="3">
+              <cx:spPr>
+                <a:solidFill>
+                  <a:srgbClr val="E00120"/>
+                </a:solidFill>
+              </cx:spPr>
+            </cx:dataLabel>
+            <cx:dataLabel idx="4" pos="outEnd">
               <cx:txPr>
                 <a:bodyPr spcFirstLastPara="1" vertOverflow="ellipsis" horzOverflow="overflow" wrap="square" lIns="0" tIns="0" rIns="0" bIns="0" anchor="ctr" anchorCtr="1"/>
                 <a:lstStyle/>
@@ -4013,23 +3988,30 @@
                   <a:pPr algn="ctr" rtl="0">
                     <a:defRPr>
                       <a:solidFill>
-                        <a:schemeClr val="bg1"/>
+                        <a:schemeClr val="tx1"/>
                       </a:solidFill>
                     </a:defRPr>
                   </a:pPr>
                   <a:r>
-                    <a:rPr lang="en-GB" sz="1000" b="1" i="0" u="none" strike="noStrike" baseline="0">
+                    <a:rPr lang="en-US" sz="1000" b="1" i="0" u="none" strike="noStrike" baseline="0">
                       <a:solidFill>
-                        <a:schemeClr val="bg1"/>
+                        <a:schemeClr val="tx1"/>
                       </a:solidFill>
                       <a:latin typeface="Arial"/>
                     </a:rPr>
-                    <a:t> 487</a:t>
+                    <a:t> 0</a:t>
                   </a:r>
                 </a:p>
               </cx:txPr>
             </cx:dataLabel>
-            <cx:dataLabel idx="3" pos="ctr">
+            <cx:dataLabel idx="5">
+              <cx:spPr>
+                <a:solidFill>
+                  <a:srgbClr val="E00120"/>
+                </a:solidFill>
+              </cx:spPr>
+            </cx:dataLabel>
+            <cx:dataLabel idx="6" pos="outEnd">
               <cx:txPr>
                 <a:bodyPr spcFirstLastPara="1" vertOverflow="ellipsis" horzOverflow="overflow" wrap="square" lIns="0" tIns="0" rIns="0" bIns="0" anchor="ctr" anchorCtr="1"/>
                 <a:lstStyle/>
@@ -4037,23 +4019,23 @@
                   <a:pPr algn="ctr" rtl="0">
                     <a:defRPr>
                       <a:solidFill>
-                        <a:schemeClr val="bg1"/>
+                        <a:schemeClr val="tx1"/>
                       </a:solidFill>
                     </a:defRPr>
                   </a:pPr>
                   <a:r>
-                    <a:rPr lang="en-GB" sz="1000" b="1" i="0" u="none" strike="noStrike" baseline="0">
+                    <a:rPr lang="en-US" sz="1000" b="1" i="0" u="none" strike="noStrike" baseline="0">
                       <a:solidFill>
-                        <a:schemeClr val="bg1"/>
+                        <a:schemeClr val="tx1"/>
                       </a:solidFill>
                       <a:latin typeface="Arial"/>
                     </a:rPr>
-                    <a:t> 141</a:t>
+                    <a:t> 0</a:t>
                   </a:r>
                 </a:p>
               </cx:txPr>
             </cx:dataLabel>
-            <cx:dataLabel idx="5" pos="ctr">
+            <cx:dataLabel idx="7" pos="outEnd">
               <cx:txPr>
                 <a:bodyPr spcFirstLastPara="1" vertOverflow="ellipsis" horzOverflow="overflow" wrap="square" lIns="0" tIns="0" rIns="0" bIns="0" anchor="ctr" anchorCtr="1"/>
                 <a:lstStyle/>
@@ -4061,18 +4043,18 @@
                   <a:pPr algn="ctr" rtl="0">
                     <a:defRPr>
                       <a:solidFill>
-                        <a:schemeClr val="bg1"/>
+                        <a:schemeClr val="tx1"/>
                       </a:solidFill>
                     </a:defRPr>
                   </a:pPr>
                   <a:r>
-                    <a:rPr lang="en-GB" sz="1000" b="1" i="0" u="none" strike="noStrike" baseline="0">
+                    <a:rPr lang="en-US" sz="1000" b="1" i="0" u="none" strike="noStrike" baseline="0">
                       <a:solidFill>
-                        <a:schemeClr val="bg1"/>
+                        <a:schemeClr val="tx1"/>
                       </a:solidFill>
                       <a:latin typeface="Arial"/>
                     </a:rPr>
-                    <a:t> 366</a:t>
+                    <a:t> 0</a:t>
                   </a:r>
                 </a:p>
               </cx:txPr>
@@ -4080,8 +4062,8 @@
           </cx:dataLabels>
           <cx:dataId val="0"/>
           <cx:layoutPr>
-            <cx:visibility connectorLines="1"/>
             <cx:subtotals>
+              <cx:idx val="0"/>
               <cx:idx val="4"/>
               <cx:idx val="6"/>
               <cx:idx val="7"/>
@@ -4095,7 +4077,7 @@
         <cx:spPr>
           <a:ln w="38100">
             <a:solidFill>
-              <a:srgbClr val="6E6E6E"/>
+              <a:srgbClr val="000000"/>
             </a:solidFill>
           </a:ln>
         </cx:spPr>
@@ -4104,13 +4086,13 @@
           <a:lstStyle/>
           <a:p>
             <a:pPr algn="ctr" rtl="0">
-              <a:defRPr b="1">
+              <a:defRPr sz="900" b="1">
                 <a:solidFill>
                   <a:schemeClr val="tx1"/>
                 </a:solidFill>
               </a:defRPr>
             </a:pPr>
-            <a:endParaRPr lang="en-GB" sz="900" b="1" i="0" u="none" strike="noStrike" baseline="0">
+            <a:endParaRPr lang="en-US" sz="900" b="1" i="0" u="none" strike="noStrike" baseline="0">
               <a:solidFill>
                 <a:schemeClr val="tx1"/>
               </a:solidFill>
@@ -4210,7 +4192,7 @@
             </cx:spPr>
           </cx:dataPt>
           <cx:dataLabels pos="ctr">
-            <cx:numFmt formatCode="#,##0" sourceLinked="0"/>
+            <cx:numFmt formatCode="# ##0;# ##0" sourceLinked="0"/>
             <cx:txPr>
               <a:bodyPr spcFirstLastPara="1" vertOverflow="ellipsis" horzOverflow="overflow" wrap="square" lIns="0" tIns="0" rIns="0" bIns="0" anchor="ctr" anchorCtr="1"/>
               <a:lstStyle/>
@@ -4231,8 +4213,15 @@
               </a:p>
             </cx:txPr>
             <cx:visibility seriesName="0" categoryName="0" value="1"/>
+            <cx:dataLabel idx="2">
+              <cx:spPr>
+                <a:solidFill>
+                  <a:srgbClr val="E00120"/>
+                </a:solidFill>
+              </cx:spPr>
+            </cx:dataLabel>
             <cx:dataLabel idx="3">
-              <cx:numFmt formatCode="#,##0" sourceLinked="0"/>
+              <cx:numFmt formatCode="# ##0;# ##0" sourceLinked="0"/>
               <cx:spPr>
                 <a:solidFill>
                   <a:srgbClr val="E00120"/>
@@ -4256,14 +4245,19 @@
                       </a:solidFill>
                       <a:latin typeface="Arial"/>
                     </a:rPr>
-                    <a:t>,0</a:t>
+                    <a:t> 0</a:t>
                   </a:r>
                 </a:p>
               </cx:txPr>
               <cx:visibility seriesName="0" categoryName="0" value="1"/>
             </cx:dataLabel>
             <cx:dataLabel idx="6">
-              <cx:numFmt formatCode="#,##0" sourceLinked="0"/>
+              <cx:numFmt formatCode="# ##0;# ##0" sourceLinked="0"/>
+              <cx:spPr>
+                <a:solidFill>
+                  <a:srgbClr val="E00120"/>
+                </a:solidFill>
+              </cx:spPr>
               <cx:txPr>
                 <a:bodyPr spcFirstLastPara="1" vertOverflow="ellipsis" horzOverflow="overflow" wrap="square" lIns="0" tIns="0" rIns="0" bIns="0" anchor="ctr" anchorCtr="1"/>
                 <a:lstStyle/>
@@ -4282,7 +4276,7 @@
                       </a:solidFill>
                       <a:latin typeface="Arial"/>
                     </a:rPr>
-                    <a:t>,0</a:t>
+                    <a:t> 0</a:t>
                   </a:r>
                 </a:p>
               </cx:txPr>
@@ -5182,7 +5176,7 @@
         <a:lumOff val="35000"/>
       </a:schemeClr>
     </cs:fontRef>
-    <cs:defRPr sz="1000" kern="1200"/>
+    <cs:defRPr sz="1330" kern="1200"/>
   </cs:axisTitle>
   <cs:categoryAxis>
     <cs:lnRef idx="0"/>
@@ -5205,7 +5199,7 @@
         <a:round/>
       </a:ln>
     </cs:spPr>
-    <cs:defRPr sz="900" kern="1200"/>
+    <cs:defRPr sz="1197" kern="1200"/>
   </cs:categoryAxis>
   <cs:chartArea mods="allowNoFillOverride allowNoLineOverride">
     <cs:lnRef idx="0"/>
@@ -5228,7 +5222,7 @@
         <a:round/>
       </a:ln>
     </cs:spPr>
-    <cs:defRPr sz="1000" kern="1200"/>
+    <cs:defRPr sz="1330" kern="1200"/>
   </cs:chartArea>
   <cs:dataLabel>
     <cs:lnRef idx="0"/>
@@ -5240,7 +5234,7 @@
         <a:lumOff val="25000"/>
       </a:schemeClr>
     </cs:fontRef>
-    <cs:defRPr sz="900" kern="1200"/>
+    <cs:defRPr sz="1197" kern="1200"/>
   </cs:dataLabel>
   <cs:dataLabelCallout>
     <cs:lnRef idx="0"/>
@@ -5265,7 +5259,7 @@
         </a:solidFill>
       </a:ln>
     </cs:spPr>
-    <cs:defRPr sz="900" kern="1200"/>
+    <cs:defRPr sz="1197" kern="1200"/>
     <cs:bodyPr rot="0" spcFirstLastPara="1" vertOverflow="clip" horzOverflow="clip" vert="horz" wrap="square" lIns="36576" tIns="18288" rIns="36576" bIns="18288" anchor="ctr" anchorCtr="1">
       <a:spAutoFit/>
     </cs:bodyPr>
@@ -5368,7 +5362,7 @@
         <a:round/>
       </a:ln>
     </cs:spPr>
-    <cs:defRPr sz="900" kern="1200"/>
+    <cs:defRPr sz="1197" kern="1200"/>
   </cs:dataTable>
   <cs:downBar>
     <cs:lnRef idx="0"/>
@@ -5533,7 +5527,7 @@
         <a:lumOff val="35000"/>
       </a:schemeClr>
     </cs:fontRef>
-    <cs:defRPr sz="900" kern="1200"/>
+    <cs:defRPr sz="1197" kern="1200"/>
   </cs:legend>
   <cs:plotArea mods="allowNoFillOverride allowNoLineOverride">
     <cs:lnRef idx="0"/>
@@ -5561,7 +5555,7 @@
         <a:lumOff val="35000"/>
       </a:schemeClr>
     </cs:fontRef>
-    <cs:defRPr sz="900" kern="1200"/>
+    <cs:defRPr sz="1197" kern="1200"/>
   </cs:seriesAxis>
   <cs:seriesLine>
     <cs:lnRef idx="0"/>
@@ -5592,7 +5586,7 @@
         <a:lumOff val="35000"/>
       </a:schemeClr>
     </cs:fontRef>
-    <cs:defRPr sz="1400" b="0" kern="1200" spc="0" baseline="0"/>
+    <cs:defRPr sz="1862" b="0" kern="1200" spc="0" baseline="0"/>
   </cs:title>
   <cs:trendline>
     <cs:lnRef idx="0">
@@ -5622,7 +5616,7 @@
         <a:lumOff val="35000"/>
       </a:schemeClr>
     </cs:fontRef>
-    <cs:defRPr sz="900" kern="1200"/>
+    <cs:defRPr sz="1197" kern="1200"/>
   </cs:trendlineLabel>
   <cs:upBar>
     <cs:lnRef idx="0"/>
@@ -5656,7 +5650,7 @@
         <a:lumOff val="35000"/>
       </a:schemeClr>
     </cs:fontRef>
-    <cs:defRPr sz="900" kern="1200"/>
+    <cs:defRPr sz="1197" kern="1200"/>
   </cs:valueAxis>
   <cs:wall>
     <cs:lnRef idx="0"/>
@@ -5687,7 +5681,7 @@
         <a:lumOff val="35000"/>
       </a:schemeClr>
     </cs:fontRef>
-    <cs:defRPr sz="1000" kern="1200"/>
+    <cs:defRPr sz="1330" kern="1200"/>
   </cs:axisTitle>
   <cs:categoryAxis>
     <cs:lnRef idx="0"/>
@@ -5710,7 +5704,7 @@
         <a:round/>
       </a:ln>
     </cs:spPr>
-    <cs:defRPr sz="900" kern="1200"/>
+    <cs:defRPr sz="1197" kern="1200"/>
   </cs:categoryAxis>
   <cs:chartArea mods="allowNoFillOverride allowNoLineOverride">
     <cs:lnRef idx="0"/>
@@ -5733,7 +5727,7 @@
         <a:round/>
       </a:ln>
     </cs:spPr>
-    <cs:defRPr sz="1000" kern="1200"/>
+    <cs:defRPr sz="1330" kern="1200"/>
   </cs:chartArea>
   <cs:dataLabel>
     <cs:lnRef idx="0"/>
@@ -5745,7 +5739,7 @@
         <a:lumOff val="25000"/>
       </a:schemeClr>
     </cs:fontRef>
-    <cs:defRPr sz="900" kern="1200"/>
+    <cs:defRPr sz="1197" kern="1200"/>
   </cs:dataLabel>
   <cs:dataLabelCallout>
     <cs:lnRef idx="0"/>
@@ -5770,7 +5764,7 @@
         </a:solidFill>
       </a:ln>
     </cs:spPr>
-    <cs:defRPr sz="900" kern="1200"/>
+    <cs:defRPr sz="1197" kern="1200"/>
     <cs:bodyPr rot="0" spcFirstLastPara="1" vertOverflow="clip" horzOverflow="clip" vert="horz" wrap="square" lIns="36576" tIns="18288" rIns="36576" bIns="18288" anchor="ctr" anchorCtr="1">
       <a:spAutoFit/>
     </cs:bodyPr>
@@ -5873,7 +5867,7 @@
         <a:round/>
       </a:ln>
     </cs:spPr>
-    <cs:defRPr sz="900" kern="1200"/>
+    <cs:defRPr sz="1197" kern="1200"/>
   </cs:dataTable>
   <cs:downBar>
     <cs:lnRef idx="0"/>
@@ -6038,7 +6032,7 @@
         <a:lumOff val="35000"/>
       </a:schemeClr>
     </cs:fontRef>
-    <cs:defRPr sz="900" kern="1200"/>
+    <cs:defRPr sz="1197" kern="1200"/>
   </cs:legend>
   <cs:plotArea mods="allowNoFillOverride allowNoLineOverride">
     <cs:lnRef idx="0"/>
@@ -6066,7 +6060,7 @@
         <a:lumOff val="35000"/>
       </a:schemeClr>
     </cs:fontRef>
-    <cs:defRPr sz="900" kern="1200"/>
+    <cs:defRPr sz="1197" kern="1200"/>
   </cs:seriesAxis>
   <cs:seriesLine>
     <cs:lnRef idx="0"/>
@@ -6097,7 +6091,7 @@
         <a:lumOff val="35000"/>
       </a:schemeClr>
     </cs:fontRef>
-    <cs:defRPr sz="1400" b="0" kern="1200" spc="0" baseline="0"/>
+    <cs:defRPr sz="1862" b="0" kern="1200" spc="0" baseline="0"/>
   </cs:title>
   <cs:trendline>
     <cs:lnRef idx="0">
@@ -6127,7 +6121,7 @@
         <a:lumOff val="35000"/>
       </a:schemeClr>
     </cs:fontRef>
-    <cs:defRPr sz="900" kern="1200"/>
+    <cs:defRPr sz="1197" kern="1200"/>
   </cs:trendlineLabel>
   <cs:upBar>
     <cs:lnRef idx="0"/>
@@ -6161,7 +6155,7 @@
         <a:lumOff val="35000"/>
       </a:schemeClr>
     </cs:fontRef>
-    <cs:defRPr sz="900" kern="1200"/>
+    <cs:defRPr sz="1197" kern="1200"/>
   </cs:valueAxis>
   <cs:wall>
     <cs:lnRef idx="0"/>
@@ -6192,7 +6186,7 @@
         <a:lumOff val="35000"/>
       </a:schemeClr>
     </cs:fontRef>
-    <cs:defRPr sz="1000" kern="1200"/>
+    <cs:defRPr sz="1330" kern="1200"/>
   </cs:axisTitle>
   <cs:categoryAxis>
     <cs:lnRef idx="0"/>
@@ -6215,7 +6209,7 @@
         <a:round/>
       </a:ln>
     </cs:spPr>
-    <cs:defRPr sz="900" kern="1200"/>
+    <cs:defRPr sz="1197" kern="1200"/>
   </cs:categoryAxis>
   <cs:chartArea mods="allowNoFillOverride allowNoLineOverride">
     <cs:lnRef idx="0"/>
@@ -6238,7 +6232,7 @@
         <a:round/>
       </a:ln>
     </cs:spPr>
-    <cs:defRPr sz="1000" kern="1200"/>
+    <cs:defRPr sz="1330" kern="1200"/>
   </cs:chartArea>
   <cs:dataLabel>
     <cs:lnRef idx="0"/>
@@ -6250,7 +6244,7 @@
         <a:lumOff val="25000"/>
       </a:schemeClr>
     </cs:fontRef>
-    <cs:defRPr sz="900" kern="1200"/>
+    <cs:defRPr sz="1197" kern="1200"/>
   </cs:dataLabel>
   <cs:dataLabelCallout>
     <cs:lnRef idx="0"/>
@@ -6275,7 +6269,7 @@
         </a:solidFill>
       </a:ln>
     </cs:spPr>
-    <cs:defRPr sz="900" kern="1200"/>
+    <cs:defRPr sz="1197" kern="1200"/>
     <cs:bodyPr rot="0" spcFirstLastPara="1" vertOverflow="clip" horzOverflow="clip" vert="horz" wrap="square" lIns="36576" tIns="18288" rIns="36576" bIns="18288" anchor="ctr" anchorCtr="1">
       <a:spAutoFit/>
     </cs:bodyPr>
@@ -6378,7 +6372,7 @@
         <a:round/>
       </a:ln>
     </cs:spPr>
-    <cs:defRPr sz="900" kern="1200"/>
+    <cs:defRPr sz="1197" kern="1200"/>
   </cs:dataTable>
   <cs:downBar>
     <cs:lnRef idx="0"/>
@@ -6543,7 +6537,7 @@
         <a:lumOff val="35000"/>
       </a:schemeClr>
     </cs:fontRef>
-    <cs:defRPr sz="900" kern="1200"/>
+    <cs:defRPr sz="1197" kern="1200"/>
   </cs:legend>
   <cs:plotArea mods="allowNoFillOverride allowNoLineOverride">
     <cs:lnRef idx="0"/>
@@ -6571,7 +6565,7 @@
         <a:lumOff val="35000"/>
       </a:schemeClr>
     </cs:fontRef>
-    <cs:defRPr sz="900" kern="1200"/>
+    <cs:defRPr sz="1197" kern="1200"/>
   </cs:seriesAxis>
   <cs:seriesLine>
     <cs:lnRef idx="0"/>
@@ -6602,7 +6596,7 @@
         <a:lumOff val="35000"/>
       </a:schemeClr>
     </cs:fontRef>
-    <cs:defRPr sz="1400" b="0" kern="1200" spc="0" baseline="0"/>
+    <cs:defRPr sz="1862" b="0" kern="1200" spc="0" baseline="0"/>
   </cs:title>
   <cs:trendline>
     <cs:lnRef idx="0">
@@ -6632,7 +6626,7 @@
         <a:lumOff val="35000"/>
       </a:schemeClr>
     </cs:fontRef>
-    <cs:defRPr sz="900" kern="1200"/>
+    <cs:defRPr sz="1197" kern="1200"/>
   </cs:trendlineLabel>
   <cs:upBar>
     <cs:lnRef idx="0"/>
@@ -6666,7 +6660,7 @@
         <a:lumOff val="35000"/>
       </a:schemeClr>
     </cs:fontRef>
-    <cs:defRPr sz="900" kern="1200"/>
+    <cs:defRPr sz="1197" kern="1200"/>
   </cs:valueAxis>
   <cs:wall>
     <cs:lnRef idx="0"/>
@@ -6697,7 +6691,7 @@
         <a:lumOff val="35000"/>
       </a:schemeClr>
     </cs:fontRef>
-    <cs:defRPr sz="1000" kern="1200"/>
+    <cs:defRPr sz="1330" kern="1200"/>
   </cs:axisTitle>
   <cs:categoryAxis>
     <cs:lnRef idx="0"/>
@@ -6720,7 +6714,7 @@
         <a:round/>
       </a:ln>
     </cs:spPr>
-    <cs:defRPr sz="900" kern="1200"/>
+    <cs:defRPr sz="1197" kern="1200"/>
   </cs:categoryAxis>
   <cs:chartArea mods="allowNoFillOverride allowNoLineOverride">
     <cs:lnRef idx="0"/>
@@ -6743,7 +6737,7 @@
         <a:round/>
       </a:ln>
     </cs:spPr>
-    <cs:defRPr sz="1000" kern="1200"/>
+    <cs:defRPr sz="1330" kern="1200"/>
   </cs:chartArea>
   <cs:dataLabel>
     <cs:lnRef idx="0"/>
@@ -6755,7 +6749,7 @@
         <a:lumOff val="25000"/>
       </a:schemeClr>
     </cs:fontRef>
-    <cs:defRPr sz="900" kern="1200"/>
+    <cs:defRPr sz="1197" kern="1200"/>
   </cs:dataLabel>
   <cs:dataLabelCallout>
     <cs:lnRef idx="0"/>
@@ -6780,7 +6774,7 @@
         </a:solidFill>
       </a:ln>
     </cs:spPr>
-    <cs:defRPr sz="900" kern="1200"/>
+    <cs:defRPr sz="1197" kern="1200"/>
     <cs:bodyPr rot="0" spcFirstLastPara="1" vertOverflow="clip" horzOverflow="clip" vert="horz" wrap="square" lIns="36576" tIns="18288" rIns="36576" bIns="18288" anchor="ctr" anchorCtr="1">
       <a:spAutoFit/>
     </cs:bodyPr>
@@ -6883,7 +6877,7 @@
         <a:round/>
       </a:ln>
     </cs:spPr>
-    <cs:defRPr sz="900" kern="1200"/>
+    <cs:defRPr sz="1197" kern="1200"/>
   </cs:dataTable>
   <cs:downBar>
     <cs:lnRef idx="0"/>
@@ -7048,7 +7042,7 @@
         <a:lumOff val="35000"/>
       </a:schemeClr>
     </cs:fontRef>
-    <cs:defRPr sz="900" kern="1200"/>
+    <cs:defRPr sz="1197" kern="1200"/>
   </cs:legend>
   <cs:plotArea mods="allowNoFillOverride allowNoLineOverride">
     <cs:lnRef idx="0"/>
@@ -7076,7 +7070,7 @@
         <a:lumOff val="35000"/>
       </a:schemeClr>
     </cs:fontRef>
-    <cs:defRPr sz="900" kern="1200"/>
+    <cs:defRPr sz="1197" kern="1200"/>
   </cs:seriesAxis>
   <cs:seriesLine>
     <cs:lnRef idx="0"/>
@@ -7107,7 +7101,7 @@
         <a:lumOff val="35000"/>
       </a:schemeClr>
     </cs:fontRef>
-    <cs:defRPr sz="1400" b="0" kern="1200" spc="0" baseline="0"/>
+    <cs:defRPr sz="1862" b="0" kern="1200" spc="0" baseline="0"/>
   </cs:title>
   <cs:trendline>
     <cs:lnRef idx="0">
@@ -7137,7 +7131,7 @@
         <a:lumOff val="35000"/>
       </a:schemeClr>
     </cs:fontRef>
-    <cs:defRPr sz="900" kern="1200"/>
+    <cs:defRPr sz="1197" kern="1200"/>
   </cs:trendlineLabel>
   <cs:upBar>
     <cs:lnRef idx="0"/>
@@ -7171,7 +7165,7 @@
         <a:lumOff val="35000"/>
       </a:schemeClr>
     </cs:fontRef>
-    <cs:defRPr sz="900" kern="1200"/>
+    <cs:defRPr sz="1197" kern="1200"/>
   </cs:valueAxis>
   <cs:wall>
     <cs:lnRef idx="0"/>
@@ -7202,7 +7196,7 @@
         <a:lumOff val="35000"/>
       </a:schemeClr>
     </cs:fontRef>
-    <cs:defRPr sz="1000" kern="1200"/>
+    <cs:defRPr sz="1330" kern="1200"/>
   </cs:axisTitle>
   <cs:categoryAxis>
     <cs:lnRef idx="0"/>
@@ -7225,7 +7219,7 @@
         <a:round/>
       </a:ln>
     </cs:spPr>
-    <cs:defRPr sz="900" kern="1200"/>
+    <cs:defRPr sz="1197" kern="1200"/>
   </cs:categoryAxis>
   <cs:chartArea mods="allowNoFillOverride allowNoLineOverride">
     <cs:lnRef idx="0"/>
@@ -7248,7 +7242,7 @@
         <a:round/>
       </a:ln>
     </cs:spPr>
-    <cs:defRPr sz="1000" kern="1200"/>
+    <cs:defRPr sz="1330" kern="1200"/>
   </cs:chartArea>
   <cs:dataLabel>
     <cs:lnRef idx="0"/>
@@ -7260,7 +7254,7 @@
         <a:lumOff val="25000"/>
       </a:schemeClr>
     </cs:fontRef>
-    <cs:defRPr sz="900" kern="1200"/>
+    <cs:defRPr sz="1197" kern="1200"/>
   </cs:dataLabel>
   <cs:dataLabelCallout>
     <cs:lnRef idx="0"/>
@@ -7285,7 +7279,7 @@
         </a:solidFill>
       </a:ln>
     </cs:spPr>
-    <cs:defRPr sz="900" kern="1200"/>
+    <cs:defRPr sz="1197" kern="1200"/>
     <cs:bodyPr rot="0" spcFirstLastPara="1" vertOverflow="clip" horzOverflow="clip" vert="horz" wrap="square" lIns="36576" tIns="18288" rIns="36576" bIns="18288" anchor="ctr" anchorCtr="1">
       <a:spAutoFit/>
     </cs:bodyPr>
@@ -7388,7 +7382,7 @@
         <a:round/>
       </a:ln>
     </cs:spPr>
-    <cs:defRPr sz="900" kern="1200"/>
+    <cs:defRPr sz="1197" kern="1200"/>
   </cs:dataTable>
   <cs:downBar>
     <cs:lnRef idx="0"/>
@@ -7553,7 +7547,7 @@
         <a:lumOff val="35000"/>
       </a:schemeClr>
     </cs:fontRef>
-    <cs:defRPr sz="900" kern="1200"/>
+    <cs:defRPr sz="1197" kern="1200"/>
   </cs:legend>
   <cs:plotArea mods="allowNoFillOverride allowNoLineOverride">
     <cs:lnRef idx="0"/>
@@ -7581,7 +7575,7 @@
         <a:lumOff val="35000"/>
       </a:schemeClr>
     </cs:fontRef>
-    <cs:defRPr sz="900" kern="1200"/>
+    <cs:defRPr sz="1197" kern="1200"/>
   </cs:seriesAxis>
   <cs:seriesLine>
     <cs:lnRef idx="0"/>
@@ -7612,7 +7606,7 @@
         <a:lumOff val="35000"/>
       </a:schemeClr>
     </cs:fontRef>
-    <cs:defRPr sz="1400" b="0" kern="1200" spc="0" baseline="0"/>
+    <cs:defRPr sz="1862" b="0" kern="1200" spc="0" baseline="0"/>
   </cs:title>
   <cs:trendline>
     <cs:lnRef idx="0">
@@ -7642,7 +7636,7 @@
         <a:lumOff val="35000"/>
       </a:schemeClr>
     </cs:fontRef>
-    <cs:defRPr sz="900" kern="1200"/>
+    <cs:defRPr sz="1197" kern="1200"/>
   </cs:trendlineLabel>
   <cs:upBar>
     <cs:lnRef idx="0"/>
@@ -7676,7 +7670,7 @@
         <a:lumOff val="35000"/>
       </a:schemeClr>
     </cs:fontRef>
-    <cs:defRPr sz="900" kern="1200"/>
+    <cs:defRPr sz="1197" kern="1200"/>
   </cs:valueAxis>
   <cs:wall>
     <cs:lnRef idx="0"/>
@@ -7707,7 +7701,7 @@
         <a:lumOff val="35000"/>
       </a:schemeClr>
     </cs:fontRef>
-    <cs:defRPr sz="900"/>
+    <cs:defRPr sz="1197"/>
   </cs:axisTitle>
   <cs:categoryAxis>
     <cs:lnRef idx="0"/>
@@ -7730,7 +7724,7 @@
         <a:round/>
       </a:ln>
     </cs:spPr>
-    <cs:defRPr sz="900"/>
+    <cs:defRPr sz="1197"/>
   </cs:categoryAxis>
   <cs:chartArea mods="allowNoFillOverride allowNoLineOverride">
     <cs:lnRef idx="0"/>
@@ -7753,7 +7747,7 @@
         <a:round/>
       </a:ln>
     </cs:spPr>
-    <cs:defRPr sz="1000"/>
+    <cs:defRPr sz="1330"/>
   </cs:chartArea>
   <cs:dataLabel>
     <cs:lnRef idx="0"/>
@@ -7765,7 +7759,7 @@
         <a:lumOff val="35000"/>
       </a:schemeClr>
     </cs:fontRef>
-    <cs:defRPr sz="900"/>
+    <cs:defRPr sz="1197"/>
   </cs:dataLabel>
   <cs:dataLabelCallout>
     <cs:lnRef idx="0"/>
@@ -7790,7 +7784,7 @@
         </a:solidFill>
       </a:ln>
     </cs:spPr>
-    <cs:defRPr sz="900"/>
+    <cs:defRPr sz="1197"/>
     <cs:bodyPr rot="0" spcFirstLastPara="1" vertOverflow="clip" horzOverflow="clip" vert="horz" wrap="square" lIns="36576" tIns="18288" rIns="36576" bIns="18288" anchor="ctr" anchorCtr="1">
       <a:spAutoFit/>
     </cs:bodyPr>
@@ -7902,7 +7896,7 @@
         </a:solidFill>
       </a:ln>
     </cs:spPr>
-    <cs:defRPr sz="900"/>
+    <cs:defRPr sz="1197"/>
   </cs:dataTable>
   <cs:downBar>
     <cs:lnRef idx="0"/>
@@ -8060,7 +8054,7 @@
         <a:lumOff val="35000"/>
       </a:schemeClr>
     </cs:fontRef>
-    <cs:defRPr sz="900"/>
+    <cs:defRPr sz="1197"/>
   </cs:legend>
   <cs:plotArea mods="allowNoFillOverride allowNoLineOverride">
     <cs:lnRef idx="0"/>
@@ -8099,7 +8093,7 @@
         <a:round/>
       </a:ln>
     </cs:spPr>
-    <cs:defRPr sz="900"/>
+    <cs:defRPr sz="1197"/>
   </cs:seriesAxis>
   <cs:seriesLine>
     <cs:lnRef idx="0"/>
@@ -8127,7 +8121,7 @@
         <a:lumOff val="35000"/>
       </a:schemeClr>
     </cs:fontRef>
-    <cs:defRPr sz="1400"/>
+    <cs:defRPr sz="1862"/>
   </cs:title>
   <cs:trendline>
     <cs:lnRef idx="0">
@@ -8157,7 +8151,7 @@
         <a:lumOff val="35000"/>
       </a:schemeClr>
     </cs:fontRef>
-    <cs:defRPr sz="900"/>
+    <cs:defRPr sz="1197"/>
   </cs:trendlineLabel>
   <cs:upBar>
     <cs:lnRef idx="0"/>
@@ -8190,7 +8184,7 @@
         <a:lumOff val="35000"/>
       </a:schemeClr>
     </cs:fontRef>
-    <cs:defRPr sz="900"/>
+    <cs:defRPr sz="1197"/>
   </cs:valueAxis>
   <cs:wall>
     <cs:lnRef idx="0"/>
@@ -10839,7 +10833,13 @@
   <p:cSld>
     <p:spTree>
       <p:nvGrpSpPr>
-        <p:cNvPr id="1" name="Shape 191"/>
+        <p:cNvPr id="1" name="Shape 191">
+          <a:extLst>
+            <a:ext uri="{FF2B5EF4-FFF2-40B4-BE49-F238E27FC236}">
+              <a16:creationId xmlns:a16="http://schemas.microsoft.com/office/drawing/2014/main" id="{D184D5B2-D997-7228-59EC-D410C0BDAF39}"/>
+            </a:ext>
+          </a:extLst>
+        </p:cNvPr>
         <p:cNvGrpSpPr/>
         <p:nvPr/>
       </p:nvGrpSpPr>
@@ -10853,7 +10853,13 @@
       </p:grpSpPr>
       <p:sp>
         <p:nvSpPr>
-          <p:cNvPr id="192" name="Google Shape;192;g3cbdc07648f_0_22:notes"/>
+          <p:cNvPr id="192" name="Google Shape;192;g3cbdc07648f_0_22:notes">
+            <a:extLst>
+              <a:ext uri="{FF2B5EF4-FFF2-40B4-BE49-F238E27FC236}">
+                <a16:creationId xmlns:a16="http://schemas.microsoft.com/office/drawing/2014/main" id="{9B57BE1E-E9A0-969D-EC83-16296A1E4087}"/>
+              </a:ext>
+            </a:extLst>
+          </p:cNvPr>
           <p:cNvSpPr>
             <a:spLocks noGrp="1" noRot="1" noChangeAspect="1"/>
           </p:cNvSpPr>
@@ -10894,7 +10900,13 @@
       </p:sp>
       <p:sp>
         <p:nvSpPr>
-          <p:cNvPr id="193" name="Google Shape;193;g3cbdc07648f_0_22:notes"/>
+          <p:cNvPr id="193" name="Google Shape;193;g3cbdc07648f_0_22:notes">
+            <a:extLst>
+              <a:ext uri="{FF2B5EF4-FFF2-40B4-BE49-F238E27FC236}">
+                <a16:creationId xmlns:a16="http://schemas.microsoft.com/office/drawing/2014/main" id="{14B019CB-4C1D-1A02-B786-31048EB56005}"/>
+              </a:ext>
+            </a:extLst>
+          </p:cNvPr>
           <p:cNvSpPr txBox="1">
             <a:spLocks noGrp="1"/>
           </p:cNvSpPr>
@@ -10932,7 +10944,13 @@
       </p:sp>
       <p:sp>
         <p:nvSpPr>
-          <p:cNvPr id="194" name="Google Shape;194;g3cbdc07648f_0_22:notes"/>
+          <p:cNvPr id="194" name="Google Shape;194;g3cbdc07648f_0_22:notes">
+            <a:extLst>
+              <a:ext uri="{FF2B5EF4-FFF2-40B4-BE49-F238E27FC236}">
+                <a16:creationId xmlns:a16="http://schemas.microsoft.com/office/drawing/2014/main" id="{8550A1C1-F754-C894-F631-F5FB2DE7156F}"/>
+              </a:ext>
+            </a:extLst>
+          </p:cNvPr>
           <p:cNvSpPr txBox="1">
             <a:spLocks noGrp="1"/>
           </p:cNvSpPr>
@@ -10973,6 +10991,11 @@
         </p:txBody>
       </p:sp>
     </p:spTree>
+    <p:extLst>
+      <p:ext uri="{BB962C8B-B14F-4D97-AF65-F5344CB8AC3E}">
+        <p14:creationId xmlns:p14="http://schemas.microsoft.com/office/powerpoint/2010/main" val="755865360"/>
+      </p:ext>
+    </p:extLst>
   </p:cSld>
   <p:clrMapOvr>
     <a:masterClrMapping/>
@@ -25407,7 +25430,7 @@
               <p:nvPr>
                 <p:extLst>
                   <p:ext uri="{D42A27DB-BD31-4B8C-83A1-F6EECF244321}">
-                    <p14:modId xmlns:p14="http://schemas.microsoft.com/office/powerpoint/2010/main" val="3147706744"/>
+                    <p14:modId xmlns:p14="http://schemas.microsoft.com/office/powerpoint/2010/main" val="561688604"/>
                   </p:ext>
                 </p:extLst>
               </p:nvPr>
@@ -26375,36 +26398,6 @@
           </a:p>
         </p:txBody>
       </p:sp>
-      <p:graphicFrame>
-        <p:nvGraphicFramePr>
-          <p:cNvPr id="21" name="Chart 20">
-            <a:extLst>
-              <a:ext uri="{FF2B5EF4-FFF2-40B4-BE49-F238E27FC236}">
-                <a16:creationId xmlns:a16="http://schemas.microsoft.com/office/drawing/2014/main" id="{0DAC5825-F814-B13C-D52D-9D91D92EC8DD}"/>
-              </a:ext>
-            </a:extLst>
-          </p:cNvPr>
-          <p:cNvGraphicFramePr>
-            <a:graphicFrameLocks/>
-          </p:cNvGraphicFramePr>
-          <p:nvPr>
-            <p:extLst>
-              <p:ext uri="{D42A27DB-BD31-4B8C-83A1-F6EECF244321}">
-                <p14:modId xmlns:p14="http://schemas.microsoft.com/office/powerpoint/2010/main" val="1901831653"/>
-              </p:ext>
-            </p:extLst>
-          </p:nvPr>
-        </p:nvGraphicFramePr>
-        <p:xfrm>
-          <a:off x="544474" y="1520564"/>
-          <a:ext cx="6645416" cy="627389"/>
-        </p:xfrm>
-        <a:graphic>
-          <a:graphicData uri="http://schemas.openxmlformats.org/drawingml/2006/chart">
-            <c:chart xmlns:c="http://schemas.openxmlformats.org/drawingml/2006/chart" xmlns:r="http://schemas.openxmlformats.org/officeDocument/2006/relationships" r:id="rId3"/>
-          </a:graphicData>
-        </a:graphic>
-      </p:graphicFrame>
       <p:sp>
         <p:nvSpPr>
           <p:cNvPr id="22" name="Google Shape;101;g3868a5fe0ff_0_109">
@@ -26727,7 +26720,7 @@
           <p:nvPr/>
         </p:nvPicPr>
         <p:blipFill rotWithShape="1">
-          <a:blip r:embed="rId4">
+          <a:blip r:embed="rId3">
             <a:alphaModFix/>
           </a:blip>
           <a:srcRect l="80294" t="91228" r="5909" b="2335"/>
@@ -26803,356 +26796,6 @@
           </a:p>
         </p:txBody>
       </p:sp>
-      <p:graphicFrame>
-        <p:nvGraphicFramePr>
-          <p:cNvPr id="32" name="Chart 31">
-            <a:extLst>
-              <a:ext uri="{FF2B5EF4-FFF2-40B4-BE49-F238E27FC236}">
-                <a16:creationId xmlns:a16="http://schemas.microsoft.com/office/drawing/2014/main" id="{6681DBAE-096F-9621-B468-E58A0235E407}"/>
-              </a:ext>
-            </a:extLst>
-          </p:cNvPr>
-          <p:cNvGraphicFramePr>
-            <a:graphicFrameLocks/>
-          </p:cNvGraphicFramePr>
-          <p:nvPr>
-            <p:extLst>
-              <p:ext uri="{D42A27DB-BD31-4B8C-83A1-F6EECF244321}">
-                <p14:modId xmlns:p14="http://schemas.microsoft.com/office/powerpoint/2010/main" val="165265957"/>
-              </p:ext>
-            </p:extLst>
-          </p:nvPr>
-        </p:nvGraphicFramePr>
-        <p:xfrm>
-          <a:off x="557751" y="2387912"/>
-          <a:ext cx="6645416" cy="932505"/>
-        </p:xfrm>
-        <a:graphic>
-          <a:graphicData uri="http://schemas.openxmlformats.org/drawingml/2006/chart">
-            <c:chart xmlns:c="http://schemas.openxmlformats.org/drawingml/2006/chart" xmlns:r="http://schemas.openxmlformats.org/officeDocument/2006/relationships" r:id="rId5"/>
-          </a:graphicData>
-        </a:graphic>
-      </p:graphicFrame>
-      <p:graphicFrame>
-        <p:nvGraphicFramePr>
-          <p:cNvPr id="33" name="Chart 32">
-            <a:extLst>
-              <a:ext uri="{FF2B5EF4-FFF2-40B4-BE49-F238E27FC236}">
-                <a16:creationId xmlns:a16="http://schemas.microsoft.com/office/drawing/2014/main" id="{7CFC0749-6AED-2F9E-8DF0-1EF001118D9A}"/>
-              </a:ext>
-            </a:extLst>
-          </p:cNvPr>
-          <p:cNvGraphicFramePr>
-            <a:graphicFrameLocks/>
-          </p:cNvGraphicFramePr>
-          <p:nvPr>
-            <p:extLst>
-              <p:ext uri="{D42A27DB-BD31-4B8C-83A1-F6EECF244321}">
-                <p14:modId xmlns:p14="http://schemas.microsoft.com/office/powerpoint/2010/main" val="2673941417"/>
-              </p:ext>
-            </p:extLst>
-          </p:nvPr>
-        </p:nvGraphicFramePr>
-        <p:xfrm>
-          <a:off x="544474" y="3501104"/>
-          <a:ext cx="6645416" cy="865439"/>
-        </p:xfrm>
-        <a:graphic>
-          <a:graphicData uri="http://schemas.openxmlformats.org/drawingml/2006/chart">
-            <c:chart xmlns:c="http://schemas.openxmlformats.org/drawingml/2006/chart" xmlns:r="http://schemas.openxmlformats.org/officeDocument/2006/relationships" r:id="rId6"/>
-          </a:graphicData>
-        </a:graphic>
-      </p:graphicFrame>
-      <p:graphicFrame>
-        <p:nvGraphicFramePr>
-          <p:cNvPr id="34" name="Chart 33">
-            <a:extLst>
-              <a:ext uri="{FF2B5EF4-FFF2-40B4-BE49-F238E27FC236}">
-                <a16:creationId xmlns:a16="http://schemas.microsoft.com/office/drawing/2014/main" id="{3834794D-CD1B-33B4-DD6A-2DF736729F81}"/>
-              </a:ext>
-            </a:extLst>
-          </p:cNvPr>
-          <p:cNvGraphicFramePr>
-            <a:graphicFrameLocks/>
-          </p:cNvGraphicFramePr>
-          <p:nvPr>
-            <p:extLst>
-              <p:ext uri="{D42A27DB-BD31-4B8C-83A1-F6EECF244321}">
-                <p14:modId xmlns:p14="http://schemas.microsoft.com/office/powerpoint/2010/main" val="2626631796"/>
-              </p:ext>
-            </p:extLst>
-          </p:nvPr>
-        </p:nvGraphicFramePr>
-        <p:xfrm>
-          <a:off x="544474" y="4449053"/>
-          <a:ext cx="6645416" cy="1081306"/>
-        </p:xfrm>
-        <a:graphic>
-          <a:graphicData uri="http://schemas.openxmlformats.org/drawingml/2006/chart">
-            <c:chart xmlns:c="http://schemas.openxmlformats.org/drawingml/2006/chart" xmlns:r="http://schemas.openxmlformats.org/officeDocument/2006/relationships" r:id="rId7"/>
-          </a:graphicData>
-        </a:graphic>
-      </p:graphicFrame>
-      <p:graphicFrame>
-        <p:nvGraphicFramePr>
-          <p:cNvPr id="35" name="Chart 34">
-            <a:extLst>
-              <a:ext uri="{FF2B5EF4-FFF2-40B4-BE49-F238E27FC236}">
-                <a16:creationId xmlns:a16="http://schemas.microsoft.com/office/drawing/2014/main" id="{04EE5D08-0C90-618F-8ACC-E60C52A74369}"/>
-              </a:ext>
-            </a:extLst>
-          </p:cNvPr>
-          <p:cNvGraphicFramePr>
-            <a:graphicFrameLocks/>
-          </p:cNvGraphicFramePr>
-          <p:nvPr>
-            <p:extLst>
-              <p:ext uri="{D42A27DB-BD31-4B8C-83A1-F6EECF244321}">
-                <p14:modId xmlns:p14="http://schemas.microsoft.com/office/powerpoint/2010/main" val="781332658"/>
-              </p:ext>
-            </p:extLst>
-          </p:nvPr>
-        </p:nvGraphicFramePr>
-        <p:xfrm>
-          <a:off x="594780" y="5804453"/>
-          <a:ext cx="6645416" cy="981190"/>
-        </p:xfrm>
-        <a:graphic>
-          <a:graphicData uri="http://schemas.openxmlformats.org/drawingml/2006/chart">
-            <c:chart xmlns:c="http://schemas.openxmlformats.org/drawingml/2006/chart" xmlns:r="http://schemas.openxmlformats.org/officeDocument/2006/relationships" r:id="rId8"/>
-          </a:graphicData>
-        </a:graphic>
-      </p:graphicFrame>
-      <p:sp>
-        <p:nvSpPr>
-          <p:cNvPr id="36" name="Oval 35">
-            <a:extLst>
-              <a:ext uri="{FF2B5EF4-FFF2-40B4-BE49-F238E27FC236}">
-                <a16:creationId xmlns:a16="http://schemas.microsoft.com/office/drawing/2014/main" id="{065FD240-AAAD-9D3C-5635-0BB34BA2F125}"/>
-              </a:ext>
-            </a:extLst>
-          </p:cNvPr>
-          <p:cNvSpPr/>
-          <p:nvPr/>
-        </p:nvSpPr>
-        <p:spPr>
-          <a:xfrm>
-            <a:off x="1450879" y="5723445"/>
-            <a:ext cx="586721" cy="244256"/>
-          </a:xfrm>
-          <a:prstGeom prst="ellipse">
-            <a:avLst/>
-          </a:prstGeom>
-          <a:solidFill>
-            <a:schemeClr val="tx2">
-              <a:lumMod val="90000"/>
-            </a:schemeClr>
-          </a:solidFill>
-          <a:ln w="19050">
-            <a:solidFill>
-              <a:schemeClr val="tx2">
-                <a:lumMod val="50000"/>
-              </a:schemeClr>
-            </a:solidFill>
-          </a:ln>
-        </p:spPr>
-        <p:style>
-          <a:lnRef idx="2">
-            <a:schemeClr val="accent1">
-              <a:shade val="15000"/>
-            </a:schemeClr>
-          </a:lnRef>
-          <a:fillRef idx="1">
-            <a:schemeClr val="accent1"/>
-          </a:fillRef>
-          <a:effectRef idx="0">
-            <a:schemeClr val="accent1"/>
-          </a:effectRef>
-          <a:fontRef idx="minor">
-            <a:schemeClr val="lt1"/>
-          </a:fontRef>
-        </p:style>
-        <p:txBody>
-          <a:bodyPr rtlCol="0" anchor="ctr"/>
-          <a:lstStyle/>
-          <a:p>
-            <a:pPr algn="ctr"/>
-            <a:r>
-              <a:rPr lang="en-HU" sz="700" dirty="0">
-                <a:solidFill>
-                  <a:schemeClr val="tx1"/>
-                </a:solidFill>
-              </a:rPr>
-              <a:t>16</a:t>
-            </a:r>
-          </a:p>
-        </p:txBody>
-      </p:sp>
-      <p:sp>
-        <p:nvSpPr>
-          <p:cNvPr id="37" name="Oval 36">
-            <a:extLst>
-              <a:ext uri="{FF2B5EF4-FFF2-40B4-BE49-F238E27FC236}">
-                <a16:creationId xmlns:a16="http://schemas.microsoft.com/office/drawing/2014/main" id="{EFB31A53-432D-8CA2-24F3-C14907C5A94A}"/>
-              </a:ext>
-            </a:extLst>
-          </p:cNvPr>
-          <p:cNvSpPr/>
-          <p:nvPr/>
-        </p:nvSpPr>
-        <p:spPr>
-          <a:xfrm>
-            <a:off x="3587098" y="5728544"/>
-            <a:ext cx="586721" cy="244256"/>
-          </a:xfrm>
-          <a:prstGeom prst="ellipse">
-            <a:avLst/>
-          </a:prstGeom>
-          <a:solidFill>
-            <a:schemeClr val="tx2">
-              <a:lumMod val="90000"/>
-            </a:schemeClr>
-          </a:solidFill>
-          <a:ln w="19050">
-            <a:solidFill>
-              <a:schemeClr val="tx2">
-                <a:lumMod val="50000"/>
-              </a:schemeClr>
-            </a:solidFill>
-          </a:ln>
-        </p:spPr>
-        <p:style>
-          <a:lnRef idx="2">
-            <a:schemeClr val="accent1">
-              <a:shade val="15000"/>
-            </a:schemeClr>
-          </a:lnRef>
-          <a:fillRef idx="1">
-            <a:schemeClr val="accent1"/>
-          </a:fillRef>
-          <a:effectRef idx="0">
-            <a:schemeClr val="accent1"/>
-          </a:effectRef>
-          <a:fontRef idx="minor">
-            <a:schemeClr val="lt1"/>
-          </a:fontRef>
-        </p:style>
-        <p:txBody>
-          <a:bodyPr rtlCol="0" anchor="ctr"/>
-          <a:lstStyle/>
-          <a:p>
-            <a:pPr algn="ctr"/>
-            <a:r>
-              <a:rPr lang="en-HU" sz="700" dirty="0">
-                <a:solidFill>
-                  <a:schemeClr val="tx1"/>
-                </a:solidFill>
-              </a:rPr>
-              <a:t>-2</a:t>
-            </a:r>
-          </a:p>
-        </p:txBody>
-      </p:sp>
-      <p:sp>
-        <p:nvSpPr>
-          <p:cNvPr id="38" name="Oval 37">
-            <a:extLst>
-              <a:ext uri="{FF2B5EF4-FFF2-40B4-BE49-F238E27FC236}">
-                <a16:creationId xmlns:a16="http://schemas.microsoft.com/office/drawing/2014/main" id="{094F7DF1-FFD6-E5E0-AFAD-AC4E539F04A9}"/>
-              </a:ext>
-            </a:extLst>
-          </p:cNvPr>
-          <p:cNvSpPr/>
-          <p:nvPr/>
-        </p:nvSpPr>
-        <p:spPr>
-          <a:xfrm>
-            <a:off x="5723317" y="5737639"/>
-            <a:ext cx="586721" cy="244256"/>
-          </a:xfrm>
-          <a:prstGeom prst="ellipse">
-            <a:avLst/>
-          </a:prstGeom>
-          <a:solidFill>
-            <a:schemeClr val="tx2">
-              <a:lumMod val="90000"/>
-            </a:schemeClr>
-          </a:solidFill>
-          <a:ln w="19050">
-            <a:solidFill>
-              <a:schemeClr val="tx2">
-                <a:lumMod val="50000"/>
-              </a:schemeClr>
-            </a:solidFill>
-          </a:ln>
-        </p:spPr>
-        <p:style>
-          <a:lnRef idx="2">
-            <a:schemeClr val="accent1">
-              <a:shade val="15000"/>
-            </a:schemeClr>
-          </a:lnRef>
-          <a:fillRef idx="1">
-            <a:schemeClr val="accent1"/>
-          </a:fillRef>
-          <a:effectRef idx="0">
-            <a:schemeClr val="accent1"/>
-          </a:effectRef>
-          <a:fontRef idx="minor">
-            <a:schemeClr val="lt1"/>
-          </a:fontRef>
-        </p:style>
-        <p:txBody>
-          <a:bodyPr rtlCol="0" anchor="ctr"/>
-          <a:lstStyle/>
-          <a:p>
-            <a:pPr algn="ctr"/>
-            <a:r>
-              <a:rPr lang="en-HU" sz="700" dirty="0">
-                <a:solidFill>
-                  <a:schemeClr val="tx1"/>
-                </a:solidFill>
-              </a:rPr>
-              <a:t>18</a:t>
-            </a:r>
-          </a:p>
-        </p:txBody>
-      </p:sp>
-      <p:sp>
-        <p:nvSpPr>
-          <p:cNvPr id="39" name="TextBox 38">
-            <a:extLst>
-              <a:ext uri="{FF2B5EF4-FFF2-40B4-BE49-F238E27FC236}">
-                <a16:creationId xmlns:a16="http://schemas.microsoft.com/office/drawing/2014/main" id="{884F68F3-C736-E1FC-6E0D-7223BBD16DBE}"/>
-              </a:ext>
-            </a:extLst>
-          </p:cNvPr>
-          <p:cNvSpPr txBox="1"/>
-          <p:nvPr/>
-        </p:nvSpPr>
-        <p:spPr>
-          <a:xfrm>
-            <a:off x="448397" y="5757356"/>
-            <a:ext cx="1142533" cy="215444"/>
-          </a:xfrm>
-          <a:prstGeom prst="rect">
-            <a:avLst/>
-          </a:prstGeom>
-          <a:noFill/>
-        </p:spPr>
-        <p:txBody>
-          <a:bodyPr wrap="square" rtlCol="0">
-            <a:spAutoFit/>
-          </a:bodyPr>
-          <a:lstStyle/>
-          <a:p>
-            <a:r>
-              <a:rPr lang="en-HU" sz="800" b="1" i="1" dirty="0"/>
-              <a:t>Deferred tax →</a:t>
-            </a:r>
-          </a:p>
-        </p:txBody>
-      </p:sp>
       <p:pic>
         <p:nvPicPr>
           <p:cNvPr id="1028" name="Picture 4">
@@ -27168,7 +26811,7 @@
           <p:nvPr/>
         </p:nvPicPr>
         <p:blipFill>
-          <a:blip r:embed="rId9">
+          <a:blip r:embed="rId4">
             <a:extLst>
               <a:ext uri="{28A0092B-C50C-407E-A947-70E740481C1C}">
                 <a14:useLocalDpi xmlns:a14="http://schemas.microsoft.com/office/drawing/2010/main" val="0"/>
@@ -27344,6 +26987,146 @@
           </a:p>
         </p:txBody>
       </p:sp>
+      <p:graphicFrame>
+        <p:nvGraphicFramePr>
+          <p:cNvPr id="5" name="Chart 4">
+            <a:extLst>
+              <a:ext uri="{FF2B5EF4-FFF2-40B4-BE49-F238E27FC236}">
+                <a16:creationId xmlns:a16="http://schemas.microsoft.com/office/drawing/2014/main" id="{B41546C3-2D9C-F41D-4325-D440A09DDBFB}"/>
+              </a:ext>
+            </a:extLst>
+          </p:cNvPr>
+          <p:cNvGraphicFramePr/>
+          <p:nvPr>
+            <p:extLst>
+              <p:ext uri="{D42A27DB-BD31-4B8C-83A1-F6EECF244321}">
+                <p14:modId xmlns:p14="http://schemas.microsoft.com/office/powerpoint/2010/main" val="1656945919"/>
+              </p:ext>
+            </p:extLst>
+          </p:nvPr>
+        </p:nvGraphicFramePr>
+        <p:xfrm>
+          <a:off x="545684" y="1545436"/>
+          <a:ext cx="6638479" cy="591278"/>
+        </p:xfrm>
+        <a:graphic>
+          <a:graphicData uri="http://schemas.openxmlformats.org/drawingml/2006/chart">
+            <c:chart xmlns:c="http://schemas.openxmlformats.org/drawingml/2006/chart" xmlns:r="http://schemas.openxmlformats.org/officeDocument/2006/relationships" r:id="rId5"/>
+          </a:graphicData>
+        </a:graphic>
+      </p:graphicFrame>
+      <p:graphicFrame>
+        <p:nvGraphicFramePr>
+          <p:cNvPr id="12" name="Chart 11">
+            <a:extLst>
+              <a:ext uri="{FF2B5EF4-FFF2-40B4-BE49-F238E27FC236}">
+                <a16:creationId xmlns:a16="http://schemas.microsoft.com/office/drawing/2014/main" id="{83D6DFE2-483C-DD9B-22B4-0F156B803F1A}"/>
+              </a:ext>
+            </a:extLst>
+          </p:cNvPr>
+          <p:cNvGraphicFramePr/>
+          <p:nvPr>
+            <p:extLst>
+              <p:ext uri="{D42A27DB-BD31-4B8C-83A1-F6EECF244321}">
+                <p14:modId xmlns:p14="http://schemas.microsoft.com/office/powerpoint/2010/main" val="2777341073"/>
+              </p:ext>
+            </p:extLst>
+          </p:nvPr>
+        </p:nvGraphicFramePr>
+        <p:xfrm>
+          <a:off x="555759" y="2406838"/>
+          <a:ext cx="6638479" cy="940681"/>
+        </p:xfrm>
+        <a:graphic>
+          <a:graphicData uri="http://schemas.openxmlformats.org/drawingml/2006/chart">
+            <c:chart xmlns:c="http://schemas.openxmlformats.org/drawingml/2006/chart" xmlns:r="http://schemas.openxmlformats.org/officeDocument/2006/relationships" r:id="rId6"/>
+          </a:graphicData>
+        </a:graphic>
+      </p:graphicFrame>
+      <p:graphicFrame>
+        <p:nvGraphicFramePr>
+          <p:cNvPr id="20" name="Chart 19">
+            <a:extLst>
+              <a:ext uri="{FF2B5EF4-FFF2-40B4-BE49-F238E27FC236}">
+                <a16:creationId xmlns:a16="http://schemas.microsoft.com/office/drawing/2014/main" id="{25B0F240-B093-8749-A6AA-643FD8818E02}"/>
+              </a:ext>
+            </a:extLst>
+          </p:cNvPr>
+          <p:cNvGraphicFramePr/>
+          <p:nvPr>
+            <p:extLst>
+              <p:ext uri="{D42A27DB-BD31-4B8C-83A1-F6EECF244321}">
+                <p14:modId xmlns:p14="http://schemas.microsoft.com/office/powerpoint/2010/main" val="34933684"/>
+              </p:ext>
+            </p:extLst>
+          </p:nvPr>
+        </p:nvGraphicFramePr>
+        <p:xfrm>
+          <a:off x="547029" y="4513054"/>
+          <a:ext cx="6638479" cy="1034691"/>
+        </p:xfrm>
+        <a:graphic>
+          <a:graphicData uri="http://schemas.openxmlformats.org/drawingml/2006/chart">
+            <c:chart xmlns:c="http://schemas.openxmlformats.org/drawingml/2006/chart" xmlns:r="http://schemas.openxmlformats.org/officeDocument/2006/relationships" r:id="rId7"/>
+          </a:graphicData>
+        </a:graphic>
+      </p:graphicFrame>
+      <p:graphicFrame>
+        <p:nvGraphicFramePr>
+          <p:cNvPr id="27" name="Chart 26">
+            <a:extLst>
+              <a:ext uri="{FF2B5EF4-FFF2-40B4-BE49-F238E27FC236}">
+                <a16:creationId xmlns:a16="http://schemas.microsoft.com/office/drawing/2014/main" id="{31395C44-5AA7-531A-4B5D-45894C4102E5}"/>
+              </a:ext>
+            </a:extLst>
+          </p:cNvPr>
+          <p:cNvGraphicFramePr/>
+          <p:nvPr>
+            <p:extLst>
+              <p:ext uri="{D42A27DB-BD31-4B8C-83A1-F6EECF244321}">
+                <p14:modId xmlns:p14="http://schemas.microsoft.com/office/powerpoint/2010/main" val="3001464733"/>
+              </p:ext>
+            </p:extLst>
+          </p:nvPr>
+        </p:nvGraphicFramePr>
+        <p:xfrm>
+          <a:off x="604407" y="5698578"/>
+          <a:ext cx="6638479" cy="965657"/>
+        </p:xfrm>
+        <a:graphic>
+          <a:graphicData uri="http://schemas.openxmlformats.org/drawingml/2006/chart">
+            <c:chart xmlns:c="http://schemas.openxmlformats.org/drawingml/2006/chart" xmlns:r="http://schemas.openxmlformats.org/officeDocument/2006/relationships" r:id="rId8"/>
+          </a:graphicData>
+        </a:graphic>
+      </p:graphicFrame>
+      <p:graphicFrame>
+        <p:nvGraphicFramePr>
+          <p:cNvPr id="31" name="Chart 30">
+            <a:extLst>
+              <a:ext uri="{FF2B5EF4-FFF2-40B4-BE49-F238E27FC236}">
+                <a16:creationId xmlns:a16="http://schemas.microsoft.com/office/drawing/2014/main" id="{850BBD9D-4133-4390-AEBF-AF1F29896117}"/>
+              </a:ext>
+            </a:extLst>
+          </p:cNvPr>
+          <p:cNvGraphicFramePr/>
+          <p:nvPr>
+            <p:extLst>
+              <p:ext uri="{D42A27DB-BD31-4B8C-83A1-F6EECF244321}">
+                <p14:modId xmlns:p14="http://schemas.microsoft.com/office/powerpoint/2010/main" val="1045171861"/>
+              </p:ext>
+            </p:extLst>
+          </p:nvPr>
+        </p:nvGraphicFramePr>
+        <p:xfrm>
+          <a:off x="555758" y="3390999"/>
+          <a:ext cx="6638479" cy="940681"/>
+        </p:xfrm>
+        <a:graphic>
+          <a:graphicData uri="http://schemas.openxmlformats.org/drawingml/2006/chart">
+            <c:chart xmlns:c="http://schemas.openxmlformats.org/drawingml/2006/chart" xmlns:r="http://schemas.openxmlformats.org/officeDocument/2006/relationships" r:id="rId9"/>
+          </a:graphicData>
+        </a:graphic>
+      </p:graphicFrame>
     </p:spTree>
   </p:cSld>
   <p:clrMapOvr>
@@ -27357,7 +27140,13 @@
   <p:cSld>
     <p:spTree>
       <p:nvGrpSpPr>
-        <p:cNvPr id="1" name="Shape 195"/>
+        <p:cNvPr id="1" name="Shape 195">
+          <a:extLst>
+            <a:ext uri="{FF2B5EF4-FFF2-40B4-BE49-F238E27FC236}">
+              <a16:creationId xmlns:a16="http://schemas.microsoft.com/office/drawing/2014/main" id="{A2AFC630-0BDC-84D8-1025-055303356FB2}"/>
+            </a:ext>
+          </a:extLst>
+        </p:cNvPr>
         <p:cNvGrpSpPr/>
         <p:nvPr/>
       </p:nvGrpSpPr>
@@ -27374,7 +27163,7 @@
           <p:cNvPr id="4" name="Google Shape;99;g3868a5fe0ff_0_109">
             <a:extLst>
               <a:ext uri="{FF2B5EF4-FFF2-40B4-BE49-F238E27FC236}">
-                <a16:creationId xmlns:a16="http://schemas.microsoft.com/office/drawing/2014/main" id="{89C7B397-91EA-5DEA-59E0-81C4F45F086B}"/>
+                <a16:creationId xmlns:a16="http://schemas.microsoft.com/office/drawing/2014/main" id="{E73C353D-1B70-7A04-62C5-E866464D7C11}"/>
               </a:ext>
             </a:extLst>
           </p:cNvPr>
@@ -27446,7 +27235,7 @@
           <p:cNvPr id="5" name="Google Shape;100;g3868a5fe0ff_0_109">
             <a:extLst>
               <a:ext uri="{FF2B5EF4-FFF2-40B4-BE49-F238E27FC236}">
-                <a16:creationId xmlns:a16="http://schemas.microsoft.com/office/drawing/2014/main" id="{C4AB9438-C45E-72E2-2B7C-C3009F5143D0}"/>
+                <a16:creationId xmlns:a16="http://schemas.microsoft.com/office/drawing/2014/main" id="{389E4DB8-D59A-6399-F958-F85283001EF9}"/>
               </a:ext>
             </a:extLst>
           </p:cNvPr>
@@ -27518,7 +27307,7 @@
           <p:cNvPr id="6" name="Google Shape;105;g3868a5fe0ff_0_109">
             <a:extLst>
               <a:ext uri="{FF2B5EF4-FFF2-40B4-BE49-F238E27FC236}">
-                <a16:creationId xmlns:a16="http://schemas.microsoft.com/office/drawing/2014/main" id="{76709F85-3B7F-8CF9-37AE-9650CA9234FF}"/>
+                <a16:creationId xmlns:a16="http://schemas.microsoft.com/office/drawing/2014/main" id="{886270C0-5D95-781C-9D27-972A34588583}"/>
               </a:ext>
             </a:extLst>
           </p:cNvPr>
@@ -27615,7 +27404,7 @@
           <p:cNvPr id="7" name="Google Shape;105;g3868a5fe0ff_0_109">
             <a:extLst>
               <a:ext uri="{FF2B5EF4-FFF2-40B4-BE49-F238E27FC236}">
-                <a16:creationId xmlns:a16="http://schemas.microsoft.com/office/drawing/2014/main" id="{105C30FC-302B-7ECB-492F-A27A67795537}"/>
+                <a16:creationId xmlns:a16="http://schemas.microsoft.com/office/drawing/2014/main" id="{CF54EAFA-B89C-19CE-3F40-0042F6FBD118}"/>
               </a:ext>
             </a:extLst>
           </p:cNvPr>
@@ -27688,7 +27477,7 @@
           <p:cNvPr id="8" name="Google Shape;101;g3868a5fe0ff_0_109">
             <a:extLst>
               <a:ext uri="{FF2B5EF4-FFF2-40B4-BE49-F238E27FC236}">
-                <a16:creationId xmlns:a16="http://schemas.microsoft.com/office/drawing/2014/main" id="{5A475BF3-6D03-8482-7FEF-A42670F999D9}"/>
+                <a16:creationId xmlns:a16="http://schemas.microsoft.com/office/drawing/2014/main" id="{E511E730-4BBF-8717-6E67-98641C4B0BF0}"/>
               </a:ext>
             </a:extLst>
           </p:cNvPr>
@@ -27697,8 +27486,8 @@
         </p:nvSpPr>
         <p:spPr>
           <a:xfrm>
-            <a:off x="678719" y="5188222"/>
-            <a:ext cx="10174162" cy="950960"/>
+            <a:off x="678718" y="5188222"/>
+            <a:ext cx="10865667" cy="950960"/>
           </a:xfrm>
           <a:prstGeom prst="rect">
             <a:avLst/>
@@ -27748,7 +27537,7 @@
           <p:cNvPr id="9" name="Google Shape;98;g3868a5fe0ff_0_109">
             <a:extLst>
               <a:ext uri="{FF2B5EF4-FFF2-40B4-BE49-F238E27FC236}">
-                <a16:creationId xmlns:a16="http://schemas.microsoft.com/office/drawing/2014/main" id="{91C92CFD-DC35-30BA-2737-94CF1F2E6CB0}"/>
+                <a16:creationId xmlns:a16="http://schemas.microsoft.com/office/drawing/2014/main" id="{6D703B87-6116-0A2E-A47A-9FF5D3054E96}"/>
               </a:ext>
             </a:extLst>
           </p:cNvPr>
@@ -27781,7 +27570,7 @@
           <p:cNvPr id="10" name="Google Shape;103;g3868a5fe0ff_0_109">
             <a:extLst>
               <a:ext uri="{FF2B5EF4-FFF2-40B4-BE49-F238E27FC236}">
-                <a16:creationId xmlns:a16="http://schemas.microsoft.com/office/drawing/2014/main" id="{C5FEBB8A-36B5-D1C5-F3E5-651F7309A34D}"/>
+                <a16:creationId xmlns:a16="http://schemas.microsoft.com/office/drawing/2014/main" id="{3D59C336-7739-BCD5-8146-CC48CC5D42AF}"/>
               </a:ext>
             </a:extLst>
           </p:cNvPr>
@@ -27832,14 +27621,14 @@
           </a:p>
         </p:txBody>
       </p:sp>
-      <mc:AlternateContent xmlns:mc="http://schemas.openxmlformats.org/markup-compatibility/2006" xmlns:cx1="http://schemas.microsoft.com/office/drawing/2015/9/8/chartex">
-        <mc:Choice Requires="cx1">
+      <mc:AlternateContent xmlns:mc="http://schemas.openxmlformats.org/markup-compatibility/2006">
+        <mc:Choice xmlns:cx1="http://schemas.microsoft.com/office/drawing/2015/9/8/chartex" Requires="cx1">
           <p:graphicFrame>
             <p:nvGraphicFramePr>
-              <p:cNvPr id="11" name="Chart 10">
+              <p:cNvPr id="2" name="Chart 1">
                 <a:extLst>
                   <a:ext uri="{FF2B5EF4-FFF2-40B4-BE49-F238E27FC236}">
-                    <a16:creationId xmlns:a16="http://schemas.microsoft.com/office/drawing/2014/main" id="{45AE5C34-507A-E5E6-171E-A10E8206F5D2}"/>
+                    <a16:creationId xmlns:a16="http://schemas.microsoft.com/office/drawing/2014/main" id="{EC1550EE-ED9A-307A-C441-D8ACF59BD481}"/>
                   </a:ext>
                 </a:extLst>
               </p:cNvPr>
@@ -27847,14 +27636,14 @@
               <p:nvPr>
                 <p:extLst>
                   <p:ext uri="{D42A27DB-BD31-4B8C-83A1-F6EECF244321}">
-                    <p14:modId xmlns:p14="http://schemas.microsoft.com/office/powerpoint/2010/main" val="2489058298"/>
+                    <p14:modId xmlns:p14="http://schemas.microsoft.com/office/powerpoint/2010/main" val="1275455917"/>
                   </p:ext>
                 </p:extLst>
               </p:nvPr>
             </p:nvGraphicFramePr>
             <p:xfrm>
-              <a:off x="660964" y="1350650"/>
-              <a:ext cx="10431106" cy="3377438"/>
+              <a:off x="678719" y="1350650"/>
+              <a:ext cx="10792681" cy="3169485"/>
             </p:xfrm>
             <a:graphic>
               <a:graphicData uri="http://schemas.microsoft.com/office/drawing/2014/chartex">
@@ -27863,13 +27652,13 @@
             </a:graphic>
           </p:graphicFrame>
         </mc:Choice>
-        <mc:Fallback xmlns="">
+        <mc:Fallback>
           <p:pic>
             <p:nvPicPr>
-              <p:cNvPr id="11" name="Chart 10">
+              <p:cNvPr id="2" name="Chart 1">
                 <a:extLst>
                   <a:ext uri="{FF2B5EF4-FFF2-40B4-BE49-F238E27FC236}">
-                    <a16:creationId xmlns:a16="http://schemas.microsoft.com/office/drawing/2014/main" id="{45AE5C34-507A-E5E6-171E-A10E8206F5D2}"/>
+                    <a16:creationId xmlns:a16="http://schemas.microsoft.com/office/drawing/2014/main" id="{EC1550EE-ED9A-307A-C441-D8ACF59BD481}"/>
                   </a:ext>
                 </a:extLst>
               </p:cNvPr>
@@ -27886,8 +27675,8 @@
             </p:blipFill>
             <p:spPr>
               <a:xfrm>
-                <a:off x="660964" y="1350650"/>
-                <a:ext cx="10431106" cy="3377438"/>
+                <a:off x="678719" y="1350650"/>
+                <a:ext cx="10792681" cy="3169485"/>
               </a:xfrm>
               <a:prstGeom prst="rect">
                 <a:avLst/>
@@ -27897,6 +27686,11 @@
         </mc:Fallback>
       </mc:AlternateContent>
     </p:spTree>
+    <p:extLst>
+      <p:ext uri="{BB962C8B-B14F-4D97-AF65-F5344CB8AC3E}">
+        <p14:creationId xmlns:p14="http://schemas.microsoft.com/office/powerpoint/2010/main" val="926512201"/>
+      </p:ext>
+    </p:extLst>
   </p:cSld>
   <p:clrMapOvr>
     <a:masterClrMapping/>
@@ -28120,7 +27914,7 @@
               <p:nvPr>
                 <p:extLst>
                   <p:ext uri="{D42A27DB-BD31-4B8C-83A1-F6EECF244321}">
-                    <p14:modId xmlns:p14="http://schemas.microsoft.com/office/powerpoint/2010/main" val="4292201193"/>
+                    <p14:modId xmlns:p14="http://schemas.microsoft.com/office/powerpoint/2010/main" val="3297610319"/>
                   </p:ext>
                 </p:extLst>
               </p:nvPr>

</xml_diff>

<commit_message>
feat: extended charts & update metadat
</commit_message>
<xml_diff>
--- a/workflows/mol-quarterly/template.pptx
+++ b/workflows/mol-quarterly/template.pptx
@@ -20,7 +20,7 @@
   <p:notesSz cx="6858000" cy="9144000"/>
   <p:embeddedFontLst>
     <p:embeddedFont>
-      <p:font typeface="Helvetica Neue" panose="02000503000000020004" pitchFamily="2" charset="0"/>
+      <p:font typeface="Helvetica Neue" panose="020B0604020202020204" charset="0"/>
       <p:regular r:id="rId10"/>
       <p:bold r:id="rId11"/>
       <p:italic r:id="rId12"/>
@@ -261,7 +261,7 @@
       <p15:sldGuideLst xmlns:p15="http://schemas.microsoft.com/office/powerpoint/2012/main"/>
     </p:ext>
     <p:ext uri="GoogleSlidesCustomDataVersion2">
-      <go:slidesCustomData xmlns="" xmlns:mc="http://schemas.openxmlformats.org/markup-compatibility/2006" xmlns:mv="urn:schemas-microsoft-com:mac:vml" xmlns:c="http://schemas.openxmlformats.org/drawingml/2006/chart" xmlns:dgm="http://schemas.openxmlformats.org/drawingml/2006/diagram" xmlns:o="urn:schemas-microsoft-com:office:office" xmlns:v="urn:schemas-microsoft-com:vml" xmlns:pvml="urn:schemas-microsoft-com:office:powerpoint" xmlns:com="http://schemas.openxmlformats.org/drawingml/2006/compatibility" xmlns:p14="http://schemas.microsoft.com/office/powerpoint/2010/main" xmlns:p15="http://schemas.microsoft.com/office/powerpoint/2012/main" xmlns:ahyp="http://schemas.microsoft.com/office/drawing/2018/hyperlinkcolor" xmlns:go="http://customooxmlschemas.google.com/" r:id="rId18" roundtripDataSignature="AMtx7mhZSYr+vVZ+KJ4E1GAgIhBUKXCz3Q=="/>
+      <go:slidesCustomData xmlns:go="http://customooxmlschemas.google.com/" xmlns:ahyp="http://schemas.microsoft.com/office/drawing/2018/hyperlinkcolor" xmlns:p15="http://schemas.microsoft.com/office/powerpoint/2012/main" xmlns:p14="http://schemas.microsoft.com/office/powerpoint/2010/main" xmlns:com="http://schemas.openxmlformats.org/drawingml/2006/compatibility" xmlns:pvml="urn:schemas-microsoft-com:office:powerpoint" xmlns:v="urn:schemas-microsoft-com:vml" xmlns:o="urn:schemas-microsoft-com:office:office" xmlns:dgm="http://schemas.openxmlformats.org/drawingml/2006/diagram" xmlns:c="http://schemas.openxmlformats.org/drawingml/2006/chart" xmlns:mv="urn:schemas-microsoft-com:mac:vml" xmlns:mc="http://schemas.openxmlformats.org/markup-compatibility/2006" xmlns="" r:id="rId18" roundtripDataSignature="AMtx7mhZSYr+vVZ+KJ4E1GAgIhBUKXCz3Q=="/>
     </p:ext>
   </p:extLst>
 </p:presentation>
@@ -270,7 +270,7 @@
 <file path=ppt/charts/chart1.xml><?xml version="1.0" encoding="utf-8"?>
 <c:chartSpace xmlns:c="http://schemas.openxmlformats.org/drawingml/2006/chart" xmlns:a="http://schemas.openxmlformats.org/drawingml/2006/main" xmlns:r="http://schemas.openxmlformats.org/officeDocument/2006/relationships" xmlns:c16r2="http://schemas.microsoft.com/office/drawing/2015/06/chart">
   <c:date1904 val="0"/>
-  <c:lang val="en-GB"/>
+  <c:lang val="hu-HU"/>
   <c:roundedCorners val="0"/>
   <mc:AlternateContent xmlns:mc="http://schemas.openxmlformats.org/markup-compatibility/2006">
     <mc:Choice xmlns:c14="http://schemas.microsoft.com/office/drawing/2007/8/2/chart" Requires="c14">
@@ -726,7 +726,7 @@
 <file path=ppt/charts/chart2.xml><?xml version="1.0" encoding="utf-8"?>
 <c:chartSpace xmlns:c="http://schemas.openxmlformats.org/drawingml/2006/chart" xmlns:a="http://schemas.openxmlformats.org/drawingml/2006/main" xmlns:r="http://schemas.openxmlformats.org/officeDocument/2006/relationships" xmlns:c16r2="http://schemas.microsoft.com/office/drawing/2015/06/chart">
   <c:date1904 val="0"/>
-  <c:lang val="en-GB"/>
+  <c:lang val="hu-HU"/>
   <c:roundedCorners val="0"/>
   <mc:AlternateContent xmlns:mc="http://schemas.openxmlformats.org/markup-compatibility/2006">
     <mc:Choice xmlns:c14="http://schemas.microsoft.com/office/drawing/2007/8/2/chart" Requires="c14">
@@ -1182,7 +1182,7 @@
 <file path=ppt/charts/chart3.xml><?xml version="1.0" encoding="utf-8"?>
 <c:chartSpace xmlns:c="http://schemas.openxmlformats.org/drawingml/2006/chart" xmlns:a="http://schemas.openxmlformats.org/drawingml/2006/main" xmlns:r="http://schemas.openxmlformats.org/officeDocument/2006/relationships" xmlns:c16r2="http://schemas.microsoft.com/office/drawing/2015/06/chart">
   <c:date1904 val="0"/>
-  <c:lang val="en-GB"/>
+  <c:lang val="hu-HU"/>
   <c:roundedCorners val="0"/>
   <mc:AlternateContent xmlns:mc="http://schemas.openxmlformats.org/markup-compatibility/2006">
     <mc:Choice xmlns:c14="http://schemas.microsoft.com/office/drawing/2007/8/2/chart" Requires="c14">
@@ -1638,7 +1638,7 @@
 <file path=ppt/charts/chart4.xml><?xml version="1.0" encoding="utf-8"?>
 <c:chartSpace xmlns:c="http://schemas.openxmlformats.org/drawingml/2006/chart" xmlns:a="http://schemas.openxmlformats.org/drawingml/2006/main" xmlns:r="http://schemas.openxmlformats.org/officeDocument/2006/relationships" xmlns:c16r2="http://schemas.microsoft.com/office/drawing/2015/06/chart">
   <c:date1904 val="0"/>
-  <c:lang val="en-GB"/>
+  <c:lang val="hu-HU"/>
   <c:roundedCorners val="0"/>
   <mc:AlternateContent xmlns:mc="http://schemas.openxmlformats.org/markup-compatibility/2006">
     <mc:Choice xmlns:c14="http://schemas.microsoft.com/office/drawing/2007/8/2/chart" Requires="c14">
@@ -2094,7 +2094,7 @@
 <file path=ppt/charts/chart5.xml><?xml version="1.0" encoding="utf-8"?>
 <c:chartSpace xmlns:c="http://schemas.openxmlformats.org/drawingml/2006/chart" xmlns:a="http://schemas.openxmlformats.org/drawingml/2006/main" xmlns:r="http://schemas.openxmlformats.org/officeDocument/2006/relationships" xmlns:c16r2="http://schemas.microsoft.com/office/drawing/2015/06/chart">
   <c:date1904 val="0"/>
-  <c:lang val="en-GB"/>
+  <c:lang val="hu-HU"/>
   <c:roundedCorners val="0"/>
   <mc:AlternateContent xmlns:mc="http://schemas.openxmlformats.org/markup-compatibility/2006">
     <mc:Choice xmlns:c14="http://schemas.microsoft.com/office/drawing/2007/8/2/chart" Requires="c14">
@@ -2550,7 +2550,7 @@
 <file path=ppt/charts/chart6.xml><?xml version="1.0" encoding="utf-8"?>
 <c:chartSpace xmlns:c="http://schemas.openxmlformats.org/drawingml/2006/chart" xmlns:a="http://schemas.openxmlformats.org/drawingml/2006/main" xmlns:r="http://schemas.openxmlformats.org/officeDocument/2006/relationships" xmlns:c16r2="http://schemas.microsoft.com/office/drawing/2015/06/chart">
   <c:date1904 val="0"/>
-  <c:lang val="en-GB"/>
+  <c:lang val="hu-HU"/>
   <c:roundedCorners val="1"/>
   <c:style val="2"/>
   <c:chart>
@@ -3014,7 +3014,7 @@
 <file path=ppt/charts/chart7.xml><?xml version="1.0" encoding="utf-8"?>
 <c:chartSpace xmlns:c="http://schemas.openxmlformats.org/drawingml/2006/chart" xmlns:a="http://schemas.openxmlformats.org/drawingml/2006/main" xmlns:r="http://schemas.openxmlformats.org/officeDocument/2006/relationships" xmlns:c16r2="http://schemas.microsoft.com/office/drawing/2015/06/chart">
   <c:date1904 val="0"/>
-  <c:lang val="en-GB"/>
+  <c:lang val="hu-HU"/>
   <c:roundedCorners val="1"/>
   <c:style val="2"/>
   <c:chart>
@@ -25415,8 +25415,8 @@
           </a:p>
         </p:txBody>
       </p:sp>
-      <mc:AlternateContent xmlns:mc="http://schemas.openxmlformats.org/markup-compatibility/2006">
-        <mc:Choice xmlns:cx1="http://schemas.microsoft.com/office/drawing/2015/9/8/chartex" Requires="cx1">
+      <mc:AlternateContent xmlns:mc="http://schemas.openxmlformats.org/markup-compatibility/2006" xmlns:cx1="http://schemas.microsoft.com/office/drawing/2015/9/8/chartex">
+        <mc:Choice Requires="cx1">
           <p:graphicFrame>
             <p:nvGraphicFramePr>
               <p:cNvPr id="2" name="Chart 1">
@@ -25446,7 +25446,7 @@
             </a:graphic>
           </p:graphicFrame>
         </mc:Choice>
-        <mc:Fallback>
+        <mc:Fallback xmlns="">
           <p:pic>
             <p:nvPicPr>
               <p:cNvPr id="2" name="Chart 1">
@@ -27636,14 +27636,14 @@
               <p:nvPr>
                 <p:extLst>
                   <p:ext uri="{D42A27DB-BD31-4B8C-83A1-F6EECF244321}">
-                    <p14:modId xmlns:p14="http://schemas.microsoft.com/office/powerpoint/2010/main" val="1275455917"/>
+                    <p14:modId xmlns:p14="http://schemas.microsoft.com/office/powerpoint/2010/main" val="1440105935"/>
                   </p:ext>
                 </p:extLst>
               </p:nvPr>
             </p:nvGraphicFramePr>
             <p:xfrm>
-              <a:off x="678719" y="1350650"/>
-              <a:ext cx="10792681" cy="3169485"/>
+              <a:off x="678719" y="1658475"/>
+              <a:ext cx="10792681" cy="2861660"/>
             </p:xfrm>
             <a:graphic>
               <a:graphicData uri="http://schemas.microsoft.com/office/drawing/2014/chartex">
@@ -27675,8 +27675,8 @@
             </p:blipFill>
             <p:spPr>
               <a:xfrm>
-                <a:off x="678719" y="1350650"/>
-                <a:ext cx="10792681" cy="3169485"/>
+                <a:off x="678719" y="1658475"/>
+                <a:ext cx="10792681" cy="2861660"/>
               </a:xfrm>
               <a:prstGeom prst="rect">
                 <a:avLst/>
@@ -27899,8 +27899,8 @@
           </a:p>
         </p:txBody>
       </p:sp>
-      <mc:AlternateContent xmlns:mc="http://schemas.openxmlformats.org/markup-compatibility/2006">
-        <mc:Choice xmlns:cx1="http://schemas.microsoft.com/office/drawing/2015/9/8/chartex" Requires="cx1">
+      <mc:AlternateContent xmlns:mc="http://schemas.openxmlformats.org/markup-compatibility/2006" xmlns:cx1="http://schemas.microsoft.com/office/drawing/2015/9/8/chartex">
+        <mc:Choice Requires="cx1">
           <p:graphicFrame>
             <p:nvGraphicFramePr>
               <p:cNvPr id="20" name="Chart 19">
@@ -27930,7 +27930,7 @@
             </a:graphic>
           </p:graphicFrame>
         </mc:Choice>
-        <mc:Fallback>
+        <mc:Fallback xmlns="">
           <p:pic>
             <p:nvPicPr>
               <p:cNvPr id="20" name="Chart 19">

</xml_diff>